<commit_message>
Fix scan-first flow and auto-calc honoraires
Restore immediate emargement scan with optional fiche, block admin on mobile, auto-add BROUILLON honoraires after fiche, add search/date filters to pedagogy, and migrate templates to control flow plus inject().
</commit_message>
<xml_diff>
--- a/MEMOIRE/La finalisima present_V11.pptx
+++ b/MEMOIRE/La finalisima present_V11.pptx
@@ -120,25 +120,17 @@
 </p:presentation>
 </file>
 
-<file path=ppt/revisionInfo.xml><?xml version="1.0" encoding="utf-8"?>
-<p1510:revInfo xmlns:a="http://schemas.openxmlformats.org/drawingml/2006/main" xmlns:r="http://schemas.openxmlformats.org/officeDocument/2006/relationships" xmlns:p1510="http://schemas.microsoft.com/office/powerpoint/2015/10/main">
-  <p1510:revLst>
-    <p1510:client id="{09B3EFAB-595D-413A-BCE6-1C0868C96490}" v="12" dt="2026-08-11T20:27:31.717"/>
-  </p1510:revLst>
-</p1510:revInfo>
-</file>
-
 <file path=ppt/changesInfos/changesInfo1.xml><?xml version="1.0" encoding="utf-8"?>
 <pc:chgInfo xmlns:a="http://schemas.openxmlformats.org/drawingml/2006/main" xmlns:r="http://schemas.openxmlformats.org/officeDocument/2006/relationships" xmlns:ac="http://schemas.microsoft.com/office/drawing/2013/main/command" xmlns:pc="http://schemas.microsoft.com/office/powerpoint/2013/main/command">
   <pc:docChgLst>
     <pc:chgData name="Bourama Aya" userId="bc3cf622bba950c8" providerId="LiveId" clId="{80D05DEE-435E-45B8-940D-BDCD6398AD36}"/>
     <pc:docChg chg="modSld">
-      <pc:chgData name="Bourama Aya" userId="bc3cf622bba950c8" providerId="LiveId" clId="{80D05DEE-435E-45B8-940D-BDCD6398AD36}" dt="2026-08-11T20:28:49.572" v="53"/>
+      <pc:chgData name="Bourama Aya" userId="bc3cf622bba950c8" providerId="LiveId" clId="{80D05DEE-435E-45B8-940D-BDCD6398AD36}" dt="2026-08-22T15:09:59.832" v="57" actId="255"/>
       <pc:docMkLst>
         <pc:docMk/>
       </pc:docMkLst>
       <pc:sldChg chg="addSp delSp modSp mod">
-        <pc:chgData name="Bourama Aya" userId="bc3cf622bba950c8" providerId="LiveId" clId="{80D05DEE-435E-45B8-940D-BDCD6398AD36}" dt="2026-08-11T20:28:49.572" v="53"/>
+        <pc:chgData name="Bourama Aya" userId="bc3cf622bba950c8" providerId="LiveId" clId="{80D05DEE-435E-45B8-940D-BDCD6398AD36}" dt="2026-08-22T15:09:59.832" v="57" actId="255"/>
         <pc:sldMkLst>
           <pc:docMk/>
           <pc:sldMk cId="0" sldId="256"/>
@@ -151,14 +143,6 @@
             <ac:spMk id="2" creationId="{00000000-0000-0000-0000-000000000000}"/>
           </ac:spMkLst>
         </pc:spChg>
-        <pc:spChg chg="add del mod">
-          <ac:chgData name="Bourama Aya" userId="bc3cf622bba950c8" providerId="LiveId" clId="{80D05DEE-435E-45B8-940D-BDCD6398AD36}" dt="2026-08-11T20:28:49.572" v="53"/>
-          <ac:spMkLst>
-            <pc:docMk/>
-            <pc:sldMk cId="0" sldId="256"/>
-            <ac:spMk id="5" creationId="{12430DC6-C0F6-25FD-44AA-2111B3EFCDB1}"/>
-          </ac:spMkLst>
-        </pc:spChg>
         <pc:spChg chg="mod">
           <ac:chgData name="Bourama Aya" userId="bc3cf622bba950c8" providerId="LiveId" clId="{80D05DEE-435E-45B8-940D-BDCD6398AD36}" dt="2026-08-11T20:25:20.977" v="28" actId="1076"/>
           <ac:spMkLst>
@@ -168,7 +152,7 @@
           </ac:spMkLst>
         </pc:spChg>
         <pc:spChg chg="mod">
-          <ac:chgData name="Bourama Aya" userId="bc3cf622bba950c8" providerId="LiveId" clId="{80D05DEE-435E-45B8-940D-BDCD6398AD36}" dt="2026-08-11T20:27:42.789" v="50" actId="255"/>
+          <ac:chgData name="Bourama Aya" userId="bc3cf622bba950c8" providerId="LiveId" clId="{80D05DEE-435E-45B8-940D-BDCD6398AD36}" dt="2026-08-22T15:09:45.677" v="55" actId="255"/>
           <ac:spMkLst>
             <pc:docMk/>
             <pc:sldMk cId="0" sldId="256"/>
@@ -184,7 +168,7 @@
           </ac:spMkLst>
         </pc:spChg>
         <pc:spChg chg="mod">
-          <ac:chgData name="Bourama Aya" userId="bc3cf622bba950c8" providerId="LiveId" clId="{80D05DEE-435E-45B8-940D-BDCD6398AD36}" dt="2026-08-11T20:27:48.571" v="51" actId="255"/>
+          <ac:chgData name="Bourama Aya" userId="bc3cf622bba950c8" providerId="LiveId" clId="{80D05DEE-435E-45B8-940D-BDCD6398AD36}" dt="2026-08-22T15:09:59.832" v="57" actId="255"/>
           <ac:spMkLst>
             <pc:docMk/>
             <pc:sldMk cId="0" sldId="256"/>
@@ -197,14 +181,6 @@
             <pc:docMk/>
             <pc:sldMk cId="0" sldId="256"/>
             <ac:spMk id="20" creationId="{00000000-0000-0000-0000-000000000000}"/>
-          </ac:spMkLst>
-        </pc:spChg>
-        <pc:spChg chg="mod">
-          <ac:chgData name="Bourama Aya" userId="bc3cf622bba950c8" providerId="LiveId" clId="{80D05DEE-435E-45B8-940D-BDCD6398AD36}" dt="2026-08-11T18:31:18.123" v="12" actId="1076"/>
-          <ac:spMkLst>
-            <pc:docMk/>
-            <pc:sldMk cId="0" sldId="256"/>
-            <ac:spMk id="22" creationId="{00000000-0000-0000-0000-000000000000}"/>
           </ac:spMkLst>
         </pc:spChg>
         <pc:spChg chg="mod">
@@ -1257,7 +1233,7 @@
           </a:prstGeom>
           <a:extLst>
             <a:ext uri="{C572A759-6A51-4108-AA02-DFA0A04FC94B}">
-              <ma14:wrappingTextBoxFlag xmlns="" xmlns:ma14="http://schemas.microsoft.com/office/mac/drawingml/2011/main" val="0"/>
+              <ma14:wrappingTextBoxFlag xmlns:ma14="http://schemas.microsoft.com/office/mac/drawingml/2011/main" xmlns="" val="0"/>
             </a:ext>
           </a:extLst>
         </p:spPr>
@@ -1276,7 +1252,7 @@
             <a:pPr algn="l"/>
             <a:fld id="{F7021451-1387-4CA6-816F-3879F97B5CBC}" type="slidenum">
               <a:rPr lang="en-US" b="0"/>
-              <a:t>‹N°›</a:t>
+              <a:t>‹#›</a:t>
             </a:fld>
             <a:endParaRPr lang="en-US"/>
           </a:p>
@@ -1332,7 +1308,7 @@
           </a:prstGeom>
           <a:extLst>
             <a:ext uri="{C572A759-6A51-4108-AA02-DFA0A04FC94B}">
-              <ma14:wrappingTextBoxFlag xmlns="" xmlns:ma14="http://schemas.microsoft.com/office/mac/drawingml/2011/main" val="0"/>
+              <ma14:wrappingTextBoxFlag xmlns:ma14="http://schemas.microsoft.com/office/mac/drawingml/2011/main" xmlns="" val="0"/>
             </a:ext>
           </a:extLst>
         </p:spPr>
@@ -1351,7 +1327,7 @@
             <a:pPr algn="l"/>
             <a:fld id="{F7021451-1387-4CA6-816F-3879F97B5CBC}" type="slidenum">
               <a:rPr lang="en-US" b="0"/>
-              <a:t>‹N°›</a:t>
+              <a:t>‹#›</a:t>
             </a:fld>
             <a:endParaRPr lang="en-US"/>
           </a:p>
@@ -2161,7 +2137,7 @@
               </a:tabLst>
             </a:pPr>
             <a:r>
-              <a:rPr lang="en-US" sz="1400" b="0" strike="noStrike" spc="-1" dirty="0" err="1">
+              <a:rPr lang="en-US" sz="1600" b="0" strike="noStrike" spc="-1" dirty="0" err="1">
                 <a:solidFill>
                   <a:schemeClr val="bg1"/>
                 </a:solidFill>
@@ -2170,7 +2146,7 @@
               <a:t>Présenté</a:t>
             </a:r>
             <a:r>
-              <a:rPr lang="en-US" sz="1400" b="0" strike="noStrike" spc="-1" dirty="0">
+              <a:rPr lang="en-US" sz="1600" b="0" strike="noStrike" spc="-1" dirty="0">
                 <a:solidFill>
                   <a:schemeClr val="bg1"/>
                 </a:solidFill>
@@ -2178,7 +2154,7 @@
               </a:rPr>
               <a:t> par</a:t>
             </a:r>
-            <a:endParaRPr lang="fr-FR" sz="1400" b="0" strike="noStrike" spc="-1" dirty="0">
+            <a:endParaRPr lang="fr-FR" sz="1600" b="0" strike="noStrike" spc="-1" dirty="0">
               <a:solidFill>
                 <a:schemeClr val="bg1"/>
               </a:solidFill>
@@ -2374,7 +2350,7 @@
               </a:tabLst>
             </a:pPr>
             <a:r>
-              <a:rPr lang="en-US" sz="1400" b="0" strike="noStrike" spc="-1" dirty="0">
+              <a:rPr lang="en-US" sz="1600" b="0" strike="noStrike" spc="-1" dirty="0">
                 <a:solidFill>
                   <a:schemeClr val="bg1"/>
                 </a:solidFill>
@@ -2382,7 +2358,7 @@
               </a:rPr>
               <a:t>Sous la direction de</a:t>
             </a:r>
-            <a:endParaRPr lang="fr-FR" sz="1400" b="0" strike="noStrike" spc="-1" dirty="0">
+            <a:endParaRPr lang="fr-FR" sz="1600" b="0" strike="noStrike" spc="-1" dirty="0">
               <a:solidFill>
                 <a:schemeClr val="bg1"/>
               </a:solidFill>
@@ -3116,10 +3092,10 @@
           <p:nvPr/>
         </p:nvPicPr>
         <p:blipFill>
-          <a:blip r:embed="rId4">
+          <a:blip>
             <a:extLst>
               <a:ext uri="{96DAC541-7B7A-43D3-8B79-37D633B846F1}">
-                <asvg:svgBlip xmlns:asvg="http://schemas.microsoft.com/office/drawing/2016/SVG/main" r:embed="rId5"/>
+                <asvg:svgBlip xmlns:asvg="http://schemas.microsoft.com/office/drawing/2016/SVG/main" r:embed="rId4"/>
               </a:ext>
             </a:extLst>
           </a:blip>
@@ -3257,10 +3233,10 @@
           <p:nvPr/>
         </p:nvPicPr>
         <p:blipFill>
-          <a:blip r:embed="rId6">
+          <a:blip>
             <a:extLst>
               <a:ext uri="{96DAC541-7B7A-43D3-8B79-37D633B846F1}">
-                <asvg:svgBlip xmlns:asvg="http://schemas.microsoft.com/office/drawing/2016/SVG/main" r:embed="rId7"/>
+                <asvg:svgBlip xmlns:asvg="http://schemas.microsoft.com/office/drawing/2016/SVG/main" r:embed="rId5"/>
               </a:ext>
             </a:extLst>
           </a:blip>
@@ -3398,10 +3374,10 @@
           <p:nvPr/>
         </p:nvPicPr>
         <p:blipFill>
-          <a:blip r:embed="rId8">
+          <a:blip>
             <a:extLst>
               <a:ext uri="{96DAC541-7B7A-43D3-8B79-37D633B846F1}">
-                <asvg:svgBlip xmlns:asvg="http://schemas.microsoft.com/office/drawing/2016/SVG/main" r:embed="rId9"/>
+                <asvg:svgBlip xmlns:asvg="http://schemas.microsoft.com/office/drawing/2016/SVG/main" r:embed="rId6"/>
               </a:ext>
             </a:extLst>
           </a:blip>
@@ -3582,7 +3558,7 @@
           <p:nvPr/>
         </p:nvPicPr>
         <p:blipFill>
-          <a:blip r:embed="rId10"/>
+          <a:blip r:embed="rId7"/>
           <a:stretch>
             <a:fillRect/>
           </a:stretch>
@@ -3718,7 +3694,7 @@
           <p:nvPr/>
         </p:nvPicPr>
         <p:blipFill>
-          <a:blip r:embed="rId11"/>
+          <a:blip r:embed="rId8"/>
           <a:stretch>
             <a:fillRect/>
           </a:stretch>
@@ -3854,7 +3830,7 @@
           <p:nvPr/>
         </p:nvPicPr>
         <p:blipFill>
-          <a:blip r:embed="rId12"/>
+          <a:blip r:embed="rId9"/>
           <a:stretch>
             <a:fillRect/>
           </a:stretch>
@@ -3944,7 +3920,7 @@
           <p:nvPr/>
         </p:nvPicPr>
         <p:blipFill>
-          <a:blip r:embed="rId13"/>
+          <a:blip r:embed="rId10"/>
           <a:stretch>
             <a:fillRect/>
           </a:stretch>
@@ -4474,10 +4450,10 @@
           <p:nvPr/>
         </p:nvPicPr>
         <p:blipFill>
-          <a:blip r:embed="rId5">
+          <a:blip>
             <a:extLst>
               <a:ext uri="{96DAC541-7B7A-43D3-8B79-37D633B846F1}">
-                <asvg:svgBlip xmlns:asvg="http://schemas.microsoft.com/office/drawing/2016/SVG/main" r:embed="rId6"/>
+                <asvg:svgBlip xmlns:asvg="http://schemas.microsoft.com/office/drawing/2016/SVG/main" r:embed="rId5"/>
               </a:ext>
             </a:extLst>
           </a:blip>
@@ -4615,10 +4591,10 @@
           <p:nvPr/>
         </p:nvPicPr>
         <p:blipFill>
-          <a:blip r:embed="rId7">
+          <a:blip>
             <a:extLst>
               <a:ext uri="{96DAC541-7B7A-43D3-8B79-37D633B846F1}">
-                <asvg:svgBlip xmlns:asvg="http://schemas.microsoft.com/office/drawing/2016/SVG/main" r:embed="rId8"/>
+                <asvg:svgBlip xmlns:asvg="http://schemas.microsoft.com/office/drawing/2016/SVG/main" r:embed="rId6"/>
               </a:ext>
             </a:extLst>
           </a:blip>
@@ -4868,10 +4844,10 @@
           <p:nvPr/>
         </p:nvPicPr>
         <p:blipFill>
-          <a:blip r:embed="rId9">
+          <a:blip>
             <a:extLst>
               <a:ext uri="{96DAC541-7B7A-43D3-8B79-37D633B846F1}">
-                <asvg:svgBlip xmlns:asvg="http://schemas.microsoft.com/office/drawing/2016/SVG/main" r:embed="rId10"/>
+                <asvg:svgBlip xmlns:asvg="http://schemas.microsoft.com/office/drawing/2016/SVG/main" r:embed="rId7"/>
               </a:ext>
             </a:extLst>
           </a:blip>
@@ -5045,7 +5021,7 @@
           <p:nvPr/>
         </p:nvPicPr>
         <p:blipFill>
-          <a:blip r:embed="rId11"/>
+          <a:blip r:embed="rId8"/>
           <a:stretch>
             <a:fillRect/>
           </a:stretch>
@@ -5967,10 +5943,10 @@
           <p:nvPr/>
         </p:nvPicPr>
         <p:blipFill>
-          <a:blip r:embed="rId4">
+          <a:blip>
             <a:extLst>
               <a:ext uri="{96DAC541-7B7A-43D3-8B79-37D633B846F1}">
-                <asvg:svgBlip xmlns:asvg="http://schemas.microsoft.com/office/drawing/2016/SVG/main" r:embed="rId5"/>
+                <asvg:svgBlip xmlns:asvg="http://schemas.microsoft.com/office/drawing/2016/SVG/main" r:embed="rId4"/>
               </a:ext>
             </a:extLst>
           </a:blip>
@@ -6436,10 +6412,10 @@
           <p:nvPr/>
         </p:nvPicPr>
         <p:blipFill>
-          <a:blip r:embed="rId6">
+          <a:blip>
             <a:extLst>
               <a:ext uri="{96DAC541-7B7A-43D3-8B79-37D633B846F1}">
-                <asvg:svgBlip xmlns:asvg="http://schemas.microsoft.com/office/drawing/2016/SVG/main" r:embed="rId7"/>
+                <asvg:svgBlip xmlns:asvg="http://schemas.microsoft.com/office/drawing/2016/SVG/main" r:embed="rId5"/>
               </a:ext>
             </a:extLst>
           </a:blip>
@@ -6615,7 +6591,7 @@
           <p:nvPr/>
         </p:nvPicPr>
         <p:blipFill>
-          <a:blip r:embed="rId8"/>
+          <a:blip r:embed="rId6"/>
           <a:stretch>
             <a:fillRect/>
           </a:stretch>
@@ -6639,7 +6615,7 @@
           <p:nvPr/>
         </p:nvPicPr>
         <p:blipFill>
-          <a:blip r:embed="rId9"/>
+          <a:blip r:embed="rId7"/>
           <a:stretch>
             <a:fillRect/>
           </a:stretch>
@@ -6663,7 +6639,7 @@
           <p:nvPr/>
         </p:nvPicPr>
         <p:blipFill>
-          <a:blip r:embed="rId10"/>
+          <a:blip r:embed="rId8"/>
           <a:stretch>
             <a:fillRect/>
           </a:stretch>
@@ -8683,10 +8659,10 @@
           <p:nvPr/>
         </p:nvPicPr>
         <p:blipFill>
-          <a:blip r:embed="rId4">
+          <a:blip>
             <a:extLst>
               <a:ext uri="{96DAC541-7B7A-43D3-8B79-37D633B846F1}">
-                <asvg:svgBlip xmlns:asvg="http://schemas.microsoft.com/office/drawing/2016/SVG/main" r:embed="rId5"/>
+                <asvg:svgBlip xmlns:asvg="http://schemas.microsoft.com/office/drawing/2016/SVG/main" r:embed="rId4"/>
               </a:ext>
             </a:extLst>
           </a:blip>
@@ -8719,10 +8695,10 @@
           <p:nvPr/>
         </p:nvPicPr>
         <p:blipFill>
-          <a:blip r:embed="rId6">
+          <a:blip>
             <a:extLst>
               <a:ext uri="{96DAC541-7B7A-43D3-8B79-37D633B846F1}">
-                <asvg:svgBlip xmlns:asvg="http://schemas.microsoft.com/office/drawing/2016/SVG/main" r:embed="rId7"/>
+                <asvg:svgBlip xmlns:asvg="http://schemas.microsoft.com/office/drawing/2016/SVG/main" r:embed="rId5"/>
               </a:ext>
             </a:extLst>
           </a:blip>
@@ -8991,10 +8967,10 @@
           <p:nvPr/>
         </p:nvPicPr>
         <p:blipFill>
-          <a:blip r:embed="rId8">
+          <a:blip>
             <a:extLst>
               <a:ext uri="{96DAC541-7B7A-43D3-8B79-37D633B846F1}">
-                <asvg:svgBlip xmlns:asvg="http://schemas.microsoft.com/office/drawing/2016/SVG/main" r:embed="rId9"/>
+                <asvg:svgBlip xmlns:asvg="http://schemas.microsoft.com/office/drawing/2016/SVG/main" r:embed="rId6"/>
               </a:ext>
             </a:extLst>
           </a:blip>
@@ -9361,10 +9337,10 @@
           <p:nvPr/>
         </p:nvPicPr>
         <p:blipFill>
-          <a:blip r:embed="rId10">
+          <a:blip>
             <a:extLst>
               <a:ext uri="{96DAC541-7B7A-43D3-8B79-37D633B846F1}">
-                <asvg:svgBlip xmlns:asvg="http://schemas.microsoft.com/office/drawing/2016/SVG/main" r:embed="rId11"/>
+                <asvg:svgBlip xmlns:asvg="http://schemas.microsoft.com/office/drawing/2016/SVG/main" r:embed="rId7"/>
               </a:ext>
             </a:extLst>
           </a:blip>
@@ -10291,10 +10267,10 @@
           <p:nvPr/>
         </p:nvPicPr>
         <p:blipFill>
-          <a:blip r:embed="rId4">
+          <a:blip>
             <a:extLst>
               <a:ext uri="{96DAC541-7B7A-43D3-8B79-37D633B846F1}">
-                <asvg:svgBlip xmlns:asvg="http://schemas.microsoft.com/office/drawing/2016/SVG/main" r:embed="rId5"/>
+                <asvg:svgBlip xmlns:asvg="http://schemas.microsoft.com/office/drawing/2016/SVG/main" r:embed="rId4"/>
               </a:ext>
             </a:extLst>
           </a:blip>
@@ -10394,10 +10370,10 @@
           <p:nvPr/>
         </p:nvPicPr>
         <p:blipFill>
-          <a:blip r:embed="rId6">
+          <a:blip>
             <a:extLst>
               <a:ext uri="{96DAC541-7B7A-43D3-8B79-37D633B846F1}">
-                <asvg:svgBlip xmlns:asvg="http://schemas.microsoft.com/office/drawing/2016/SVG/main" r:embed="rId7"/>
+                <asvg:svgBlip xmlns:asvg="http://schemas.microsoft.com/office/drawing/2016/SVG/main" r:embed="rId5"/>
               </a:ext>
             </a:extLst>
           </a:blip>
@@ -10497,10 +10473,10 @@
           <p:nvPr/>
         </p:nvPicPr>
         <p:blipFill>
-          <a:blip r:embed="rId8">
+          <a:blip>
             <a:extLst>
               <a:ext uri="{96DAC541-7B7A-43D3-8B79-37D633B846F1}">
-                <asvg:svgBlip xmlns:asvg="http://schemas.microsoft.com/office/drawing/2016/SVG/main" r:embed="rId9"/>
+                <asvg:svgBlip xmlns:asvg="http://schemas.microsoft.com/office/drawing/2016/SVG/main" r:embed="rId6"/>
               </a:ext>
             </a:extLst>
           </a:blip>
@@ -10674,10 +10650,10 @@
           <p:nvPr/>
         </p:nvPicPr>
         <p:blipFill>
-          <a:blip r:embed="rId10">
+          <a:blip>
             <a:extLst>
               <a:ext uri="{96DAC541-7B7A-43D3-8B79-37D633B846F1}">
-                <asvg:svgBlip xmlns:asvg="http://schemas.microsoft.com/office/drawing/2016/SVG/main" r:embed="rId11"/>
+                <asvg:svgBlip xmlns:asvg="http://schemas.microsoft.com/office/drawing/2016/SVG/main" r:embed="rId7"/>
               </a:ext>
             </a:extLst>
           </a:blip>
@@ -10777,10 +10753,10 @@
           <p:nvPr/>
         </p:nvPicPr>
         <p:blipFill>
-          <a:blip r:embed="rId12">
+          <a:blip>
             <a:extLst>
               <a:ext uri="{96DAC541-7B7A-43D3-8B79-37D633B846F1}">
-                <asvg:svgBlip xmlns:asvg="http://schemas.microsoft.com/office/drawing/2016/SVG/main" r:embed="rId13"/>
+                <asvg:svgBlip xmlns:asvg="http://schemas.microsoft.com/office/drawing/2016/SVG/main" r:embed="rId8"/>
               </a:ext>
             </a:extLst>
           </a:blip>
@@ -10954,10 +10930,10 @@
           <p:nvPr/>
         </p:nvPicPr>
         <p:blipFill>
-          <a:blip r:embed="rId14">
+          <a:blip>
             <a:extLst>
               <a:ext uri="{96DAC541-7B7A-43D3-8B79-37D633B846F1}">
-                <asvg:svgBlip xmlns:asvg="http://schemas.microsoft.com/office/drawing/2016/SVG/main" r:embed="rId15"/>
+                <asvg:svgBlip xmlns:asvg="http://schemas.microsoft.com/office/drawing/2016/SVG/main" r:embed="rId9"/>
               </a:ext>
             </a:extLst>
           </a:blip>
@@ -11057,10 +11033,10 @@
           <p:nvPr/>
         </p:nvPicPr>
         <p:blipFill>
-          <a:blip r:embed="rId16">
+          <a:blip>
             <a:extLst>
               <a:ext uri="{96DAC541-7B7A-43D3-8B79-37D633B846F1}">
-                <asvg:svgBlip xmlns:asvg="http://schemas.microsoft.com/office/drawing/2016/SVG/main" r:embed="rId17"/>
+                <asvg:svgBlip xmlns:asvg="http://schemas.microsoft.com/office/drawing/2016/SVG/main" r:embed="rId10"/>
               </a:ext>
             </a:extLst>
           </a:blip>
@@ -11160,10 +11136,10 @@
           <p:nvPr/>
         </p:nvPicPr>
         <p:blipFill>
-          <a:blip r:embed="rId18">
+          <a:blip>
             <a:extLst>
               <a:ext uri="{96DAC541-7B7A-43D3-8B79-37D633B846F1}">
-                <asvg:svgBlip xmlns:asvg="http://schemas.microsoft.com/office/drawing/2016/SVG/main" r:embed="rId19"/>
+                <asvg:svgBlip xmlns:asvg="http://schemas.microsoft.com/office/drawing/2016/SVG/main" r:embed="rId11"/>
               </a:ext>
             </a:extLst>
           </a:blip>
@@ -11263,10 +11239,10 @@
           <p:nvPr/>
         </p:nvPicPr>
         <p:blipFill>
-          <a:blip r:embed="rId20">
+          <a:blip>
             <a:extLst>
               <a:ext uri="{96DAC541-7B7A-43D3-8B79-37D633B846F1}">
-                <asvg:svgBlip xmlns:asvg="http://schemas.microsoft.com/office/drawing/2016/SVG/main" r:embed="rId21"/>
+                <asvg:svgBlip xmlns:asvg="http://schemas.microsoft.com/office/drawing/2016/SVG/main" r:embed="rId12"/>
               </a:ext>
             </a:extLst>
           </a:blip>
@@ -15613,10 +15589,10 @@
           <p:nvPr/>
         </p:nvPicPr>
         <p:blipFill>
-          <a:blip r:embed="rId4">
+          <a:blip>
             <a:extLst>
               <a:ext uri="{96DAC541-7B7A-43D3-8B79-37D633B846F1}">
-                <asvg:svgBlip xmlns:asvg="http://schemas.microsoft.com/office/drawing/2016/SVG/main" r:embed="rId5"/>
+                <asvg:svgBlip xmlns:asvg="http://schemas.microsoft.com/office/drawing/2016/SVG/main" r:embed="rId4"/>
               </a:ext>
             </a:extLst>
           </a:blip>
@@ -15754,10 +15730,10 @@
           <p:nvPr/>
         </p:nvPicPr>
         <p:blipFill>
-          <a:blip r:embed="rId6">
+          <a:blip>
             <a:extLst>
               <a:ext uri="{96DAC541-7B7A-43D3-8B79-37D633B846F1}">
-                <asvg:svgBlip xmlns:asvg="http://schemas.microsoft.com/office/drawing/2016/SVG/main" r:embed="rId7"/>
+                <asvg:svgBlip xmlns:asvg="http://schemas.microsoft.com/office/drawing/2016/SVG/main" r:embed="rId5"/>
               </a:ext>
             </a:extLst>
           </a:blip>
@@ -16075,10 +16051,10 @@
           <p:nvPr/>
         </p:nvPicPr>
         <p:blipFill>
-          <a:blip r:embed="rId8">
+          <a:blip>
             <a:extLst>
               <a:ext uri="{96DAC541-7B7A-43D3-8B79-37D633B846F1}">
-                <asvg:svgBlip xmlns:asvg="http://schemas.microsoft.com/office/drawing/2016/SVG/main" r:embed="rId9"/>
+                <asvg:svgBlip xmlns:asvg="http://schemas.microsoft.com/office/drawing/2016/SVG/main" r:embed="rId6"/>
               </a:ext>
             </a:extLst>
           </a:blip>
@@ -16216,10 +16192,10 @@
           <p:nvPr/>
         </p:nvPicPr>
         <p:blipFill>
-          <a:blip r:embed="rId10">
+          <a:blip>
             <a:extLst>
               <a:ext uri="{96DAC541-7B7A-43D3-8B79-37D633B846F1}">
-                <asvg:svgBlip xmlns:asvg="http://schemas.microsoft.com/office/drawing/2016/SVG/main" r:embed="rId11"/>
+                <asvg:svgBlip xmlns:asvg="http://schemas.microsoft.com/office/drawing/2016/SVG/main" r:embed="rId7"/>
               </a:ext>
             </a:extLst>
           </a:blip>
@@ -16357,10 +16333,10 @@
           <p:nvPr/>
         </p:nvPicPr>
         <p:blipFill>
-          <a:blip r:embed="rId12">
+          <a:blip>
             <a:extLst>
               <a:ext uri="{96DAC541-7B7A-43D3-8B79-37D633B846F1}">
-                <asvg:svgBlip xmlns:asvg="http://schemas.microsoft.com/office/drawing/2016/SVG/main" r:embed="rId13"/>
+                <asvg:svgBlip xmlns:asvg="http://schemas.microsoft.com/office/drawing/2016/SVG/main" r:embed="rId8"/>
               </a:ext>
             </a:extLst>
           </a:blip>
@@ -16574,7 +16550,7 @@
           <p:nvPr/>
         </p:nvPicPr>
         <p:blipFill>
-          <a:blip r:embed="rId14"/>
+          <a:blip r:embed="rId9"/>
           <a:stretch>
             <a:fillRect/>
           </a:stretch>
@@ -16598,7 +16574,7 @@
           <p:nvPr/>
         </p:nvPicPr>
         <p:blipFill>
-          <a:blip r:embed="rId15"/>
+          <a:blip r:embed="rId10"/>
           <a:stretch>
             <a:fillRect/>
           </a:stretch>
@@ -20165,13 +20141,13 @@
   <p:clrMapOvr>
     <a:masterClrMapping/>
   </p:clrMapOvr>
-  <mc:AlternateContent xmlns:mc="http://schemas.openxmlformats.org/markup-compatibility/2006">
-    <mc:Choice xmlns:p14="http://schemas.microsoft.com/office/powerpoint/2010/main" Requires="p14">
+  <mc:AlternateContent xmlns:mc="http://schemas.openxmlformats.org/markup-compatibility/2006" xmlns:p14="http://schemas.microsoft.com/office/powerpoint/2010/main">
+    <mc:Choice Requires="p14">
       <p:transition spd="med" p14:dur="600">
         <p:fade thruBlk="1"/>
       </p:transition>
     </mc:Choice>
-    <mc:Fallback>
+    <mc:Fallback xmlns="">
       <p:transition spd="med">
         <p:fade thruBlk="1"/>
       </p:transition>

</xml_diff>

<commit_message>
Fix mobile profile and progression flow
</commit_message>
<xml_diff>
--- a/MEMOIRE/La finalisima present_V11.pptx
+++ b/MEMOIRE/La finalisima present_V11.pptx
@@ -2757,16 +2757,12 @@
             <a:avLst/>
           </a:prstGeom>
           <a:solidFill>
-            <a:srgbClr val="0B1121">
+            <a:srgbClr val="F8FAFC">
               <a:alpha val="93000"/>
             </a:srgbClr>
           </a:solidFill>
           <a:ln w="12700">
-            <a:solidFill>
-              <a:srgbClr val="0B1121">
-                <a:alpha val="0"/>
-              </a:srgbClr>
-            </a:solidFill>
+            <a:noFill/>
             <a:prstDash val="solid"/>
           </a:ln>
         </p:spPr>
@@ -2807,7 +2803,7 @@
             <a:r>
               <a:rPr lang="en-US" sz="2900" b="1" dirty="0">
                 <a:solidFill>
-                  <a:srgbClr val="FFFFFF"/>
+                  <a:srgbClr val="0F4272"/>
                 </a:solidFill>
               </a:rPr>
               <a:t>Problématique &amp; objectifs</a:t>
@@ -2922,12 +2918,10 @@
             <a:avLst/>
           </a:prstGeom>
           <a:solidFill>
-            <a:srgbClr val="334155"/>
+            <a:srgbClr val="CBD5E1"/>
           </a:solidFill>
           <a:ln w="12700">
-            <a:solidFill>
-              <a:srgbClr val="334155"/>
-            </a:solidFill>
+            <a:noFill/>
             <a:prstDash val="solid"/>
           </a:ln>
         </p:spPr>
@@ -2966,7 +2960,7 @@
             <a:r>
               <a:rPr lang="en-US" sz="1600" dirty="0">
                 <a:solidFill>
-                  <a:srgbClr val="94A3B8"/>
+                  <a:srgbClr val="5A6E80"/>
                 </a:solidFill>
               </a:rPr>
               <a:t>EduTrack — Projet de Licence 3</a:t>
@@ -3002,7 +2996,7 @@
             <a:r>
               <a:rPr lang="en-US" sz="1600" b="1" dirty="0">
                 <a:solidFill>
-                  <a:srgbClr val="06B6D4"/>
+                  <a:srgbClr val="5A6E80"/>
                 </a:solidFill>
               </a:rPr>
               <a:t>2 / 9</a:t>
@@ -3038,7 +3032,7 @@
             <a:r>
               <a:rPr lang="en-US" sz="2400" b="1" dirty="0">
                 <a:solidFill>
-                  <a:srgbClr val="EF4444"/>
+                  <a:srgbClr val="0F4272"/>
                 </a:solidFill>
               </a:rPr>
               <a:t>Avant</a:t>
@@ -3064,13 +3058,13 @@
             </a:avLst>
           </a:prstGeom>
           <a:solidFill>
-            <a:srgbClr val="172033">
+            <a:srgbClr val="FFFFFF">
               <a:alpha val="96000"/>
             </a:srgbClr>
           </a:solidFill>
-          <a:ln w="14605">
+          <a:ln w="12700">
             <a:solidFill>
-              <a:srgbClr val="10B981"/>
+              <a:srgbClr val="D3E2EC"/>
             </a:solidFill>
             <a:prstDash val="solid"/>
           </a:ln>
@@ -3141,7 +3135,7 @@
             <a:r>
               <a:rPr lang="en-US" sz="1700" b="1" dirty="0">
                 <a:solidFill>
-                  <a:srgbClr val="FFFFFF"/>
+                  <a:srgbClr val="0F4272"/>
                 </a:solidFill>
               </a:rPr>
               <a:t>Feuilles Excel</a:t>
@@ -3179,7 +3173,7 @@
             <a:r>
               <a:rPr lang="en-US" sz="1250" dirty="0">
                 <a:solidFill>
-                  <a:srgbClr val="94A3B8"/>
+                  <a:srgbClr val="304152"/>
                 </a:solidFill>
               </a:rPr>
               <a:t>Suivi dispersé</a:t>
@@ -3205,13 +3199,13 @@
             </a:avLst>
           </a:prstGeom>
           <a:solidFill>
-            <a:srgbClr val="172033">
+            <a:srgbClr val="FFFFFF">
               <a:alpha val="96000"/>
             </a:srgbClr>
           </a:solidFill>
-          <a:ln w="14605">
+          <a:ln w="12700">
             <a:solidFill>
-              <a:srgbClr val="F59E0B"/>
+              <a:srgbClr val="D3E2EC"/>
             </a:solidFill>
             <a:prstDash val="solid"/>
           </a:ln>
@@ -3282,7 +3276,7 @@
             <a:r>
               <a:rPr lang="en-US" sz="1700" b="1" dirty="0">
                 <a:solidFill>
-                  <a:srgbClr val="FFFFFF"/>
+                  <a:srgbClr val="0F4272"/>
                 </a:solidFill>
               </a:rPr>
               <a:t>Formulaires papier</a:t>
@@ -3320,7 +3314,7 @@
             <a:r>
               <a:rPr lang="en-US" sz="1250" dirty="0">
                 <a:solidFill>
-                  <a:srgbClr val="94A3B8"/>
+                  <a:srgbClr val="304152"/>
                 </a:solidFill>
               </a:rPr>
               <a:t>Saisie manuelle</a:t>
@@ -3346,13 +3340,13 @@
             </a:avLst>
           </a:prstGeom>
           <a:solidFill>
-            <a:srgbClr val="172033">
+            <a:srgbClr val="FFFFFF">
               <a:alpha val="96000"/>
             </a:srgbClr>
           </a:solidFill>
-          <a:ln w="14605">
+          <a:ln w="12700">
             <a:solidFill>
-              <a:srgbClr val="EF4444"/>
+              <a:srgbClr val="D3E2EC"/>
             </a:solidFill>
             <a:prstDash val="solid"/>
           </a:ln>
@@ -3423,7 +3417,7 @@
             <a:r>
               <a:rPr lang="en-US" sz="1700" b="1" dirty="0">
                 <a:solidFill>
-                  <a:srgbClr val="FFFFFF"/>
+                  <a:srgbClr val="0F4272"/>
                 </a:solidFill>
               </a:rPr>
               <a:t>Données isolées</a:t>
@@ -3461,7 +3455,7 @@
             <a:r>
               <a:rPr lang="en-US" sz="1250" dirty="0">
                 <a:solidFill>
-                  <a:srgbClr val="94A3B8"/>
+                  <a:srgbClr val="304152"/>
                 </a:solidFill>
               </a:rPr>
               <a:t>Peu de traçabilité</a:t>
@@ -3495,7 +3489,7 @@
             <a:r>
               <a:rPr sz="1700" b="1">
                 <a:solidFill>
-                  <a:srgbClr val="22C55E"/>
+                  <a:srgbClr val="0F4272"/>
                 </a:solidFill>
               </a:rPr>
               <a:t>Objectifs</a:t>
@@ -3518,11 +3512,11 @@
             <a:avLst/>
           </a:prstGeom>
           <a:solidFill>
-            <a:srgbClr val="172033"/>
-          </a:solidFill>
-          <a:ln w="14605">
+            <a:srgbClr val="FFFFFF"/>
+          </a:solidFill>
+          <a:ln w="12700">
             <a:solidFill>
-              <a:srgbClr val="10B981"/>
+              <a:srgbClr val="D3E2EC"/>
             </a:solidFill>
           </a:ln>
         </p:spPr>
@@ -3598,7 +3592,7 @@
             <a:r>
               <a:rPr sz="1700" b="1">
                 <a:solidFill>
-                  <a:srgbClr val="FFFFFF"/>
+                  <a:srgbClr val="0F4272"/>
                 </a:solidFill>
               </a:rPr>
               <a:t>Centraliser</a:t>
@@ -3631,7 +3625,7 @@
             <a:r>
               <a:rPr sz="1250">
                 <a:solidFill>
-                  <a:srgbClr val="94A3B8"/>
+                  <a:srgbClr val="304152"/>
                 </a:solidFill>
               </a:rPr>
               <a:t>Tout au même endroit</a:t>
@@ -3654,11 +3648,11 @@
             <a:avLst/>
           </a:prstGeom>
           <a:solidFill>
-            <a:srgbClr val="172033"/>
-          </a:solidFill>
-          <a:ln w="14605">
+            <a:srgbClr val="FFFFFF"/>
+          </a:solidFill>
+          <a:ln w="12700">
             <a:solidFill>
-              <a:srgbClr val="10B981"/>
+              <a:srgbClr val="D3E2EC"/>
             </a:solidFill>
           </a:ln>
         </p:spPr>
@@ -3734,7 +3728,7 @@
             <a:r>
               <a:rPr sz="1700" b="1">
                 <a:solidFill>
-                  <a:srgbClr val="FFFFFF"/>
+                  <a:srgbClr val="0F4272"/>
                 </a:solidFill>
               </a:rPr>
               <a:t>Fiabiliser</a:t>
@@ -3767,7 +3761,7 @@
             <a:r>
               <a:rPr sz="1250">
                 <a:solidFill>
-                  <a:srgbClr val="94A3B8"/>
+                  <a:srgbClr val="304152"/>
                 </a:solidFill>
               </a:rPr>
               <a:t>Données vérifiées</a:t>
@@ -3790,11 +3784,11 @@
             <a:avLst/>
           </a:prstGeom>
           <a:solidFill>
-            <a:srgbClr val="172033"/>
-          </a:solidFill>
-          <a:ln w="14605">
+            <a:srgbClr val="FFFFFF"/>
+          </a:solidFill>
+          <a:ln w="12700">
             <a:solidFill>
-              <a:srgbClr val="10B981"/>
+              <a:srgbClr val="D3E2EC"/>
             </a:solidFill>
           </a:ln>
         </p:spPr>
@@ -3870,7 +3864,7 @@
             <a:r>
               <a:rPr sz="1700" b="1">
                 <a:solidFill>
-                  <a:srgbClr val="FFFFFF"/>
+                  <a:srgbClr val="0F4272"/>
                 </a:solidFill>
               </a:rPr>
               <a:t>Automatiser</a:t>
@@ -3903,7 +3897,7 @@
             <a:r>
               <a:rPr sz="1250">
                 <a:solidFill>
-                  <a:srgbClr val="94A3B8"/>
+                  <a:srgbClr val="304152"/>
                 </a:solidFill>
               </a:rPr>
               <a:t>Calculs et rapports</a:t>
@@ -4004,7 +3998,7 @@
             <a:r>
               <a:rPr sz="1100" b="1">
                 <a:solidFill>
-                  <a:srgbClr val="0F4272"/>
+                  <a:srgbClr val="304152"/>
                 </a:solidFill>
                 <a:latin typeface="Aptos"/>
               </a:rPr>
@@ -4039,7 +4033,7 @@
             <a:r>
               <a:rPr sz="900" b="0">
                 <a:solidFill>
-                  <a:srgbClr val="657A8C"/>
+                  <a:srgbClr val="304152"/>
                 </a:solidFill>
                 <a:latin typeface="Aptos"/>
               </a:rPr>
@@ -4214,16 +4208,12 @@
             <a:avLst/>
           </a:prstGeom>
           <a:solidFill>
-            <a:srgbClr val="0B1121">
+            <a:srgbClr val="F8FAFC">
               <a:alpha val="93000"/>
             </a:srgbClr>
           </a:solidFill>
           <a:ln w="12700">
-            <a:solidFill>
-              <a:srgbClr val="0B1121">
-                <a:alpha val="0"/>
-              </a:srgbClr>
-            </a:solidFill>
+            <a:noFill/>
             <a:prstDash val="solid"/>
           </a:ln>
         </p:spPr>
@@ -4264,7 +4254,7 @@
             <a:r>
               <a:rPr lang="en-US" sz="2900" b="1" dirty="0">
                 <a:solidFill>
-                  <a:srgbClr val="FFFFFF"/>
+                  <a:srgbClr val="0F4272"/>
                 </a:solidFill>
               </a:rPr>
               <a:t>Solution proposée : EduTrack</a:t>
@@ -4379,12 +4369,10 @@
             <a:avLst/>
           </a:prstGeom>
           <a:solidFill>
-            <a:srgbClr val="334155"/>
+            <a:srgbClr val="CBD5E1"/>
           </a:solidFill>
           <a:ln w="12700">
-            <a:solidFill>
-              <a:srgbClr val="334155"/>
-            </a:solidFill>
+            <a:noFill/>
             <a:prstDash val="solid"/>
           </a:ln>
         </p:spPr>
@@ -4423,7 +4411,7 @@
             <a:r>
               <a:rPr lang="en-US" sz="1600" dirty="0">
                 <a:solidFill>
-                  <a:srgbClr val="94A3B8"/>
+                  <a:srgbClr val="5A6E80"/>
                 </a:solidFill>
               </a:rPr>
               <a:t>EduTrack — Projet de Licence 3</a:t>
@@ -4459,7 +4447,7 @@
             <a:r>
               <a:rPr lang="en-US" sz="1600" b="1" dirty="0">
                 <a:solidFill>
-                  <a:srgbClr val="06B6D4"/>
+                  <a:srgbClr val="5A6E80"/>
                 </a:solidFill>
               </a:rPr>
               <a:t>3 / 9</a:t>
@@ -4552,7 +4540,7 @@
             <a:r>
               <a:rPr lang="en-US" sz="1500" b="1" dirty="0">
                 <a:solidFill>
-                  <a:srgbClr val="06B6D4"/>
+                  <a:srgbClr val="304152"/>
                 </a:solidFill>
               </a:rPr>
               <a:t>Web + Mobile</a:t>
@@ -4578,13 +4566,13 @@
             </a:avLst>
           </a:prstGeom>
           <a:solidFill>
-            <a:srgbClr val="172033">
+            <a:srgbClr val="FFFFFF">
               <a:alpha val="96000"/>
             </a:srgbClr>
           </a:solidFill>
-          <a:ln w="14605">
+          <a:ln w="12700">
             <a:solidFill>
-              <a:srgbClr val="3B82F6"/>
+              <a:srgbClr val="D3E2EC"/>
             </a:solidFill>
             <a:prstDash val="solid"/>
           </a:ln>
@@ -4655,7 +4643,7 @@
             <a:r>
               <a:rPr lang="en-US" sz="1700" b="1" dirty="0">
                 <a:solidFill>
-                  <a:srgbClr val="FFFFFF"/>
+                  <a:srgbClr val="0F4272"/>
                 </a:solidFill>
               </a:rPr>
               <a:t>Administration web</a:t>
@@ -4693,7 +4681,7 @@
             <a:r>
               <a:rPr lang="en-US" sz="1250" dirty="0">
                 <a:solidFill>
-                  <a:srgbClr val="94A3B8"/>
+                  <a:srgbClr val="304152"/>
                 </a:solidFill>
               </a:rPr>
               <a:t>Gestion, planning, suivi</a:t>
@@ -4719,13 +4707,13 @@
             </a:avLst>
           </a:prstGeom>
           <a:solidFill>
-            <a:srgbClr val="172033">
+            <a:srgbClr val="FFFFFF">
               <a:alpha val="96000"/>
             </a:srgbClr>
           </a:solidFill>
-          <a:ln w="14605">
+          <a:ln w="12700">
             <a:solidFill>
-              <a:srgbClr val="10B981"/>
+              <a:srgbClr val="D3E2EC"/>
             </a:solidFill>
             <a:prstDash val="solid"/>
           </a:ln>
@@ -4796,7 +4784,7 @@
             <a:r>
               <a:rPr lang="en-US" sz="1700" b="1" dirty="0">
                 <a:solidFill>
-                  <a:srgbClr val="FFFFFF"/>
+                  <a:srgbClr val="0F4272"/>
                 </a:solidFill>
               </a:rPr>
               <a:t>Émargement QR</a:t>
@@ -4834,7 +4822,7 @@
             <a:r>
               <a:rPr lang="en-US" sz="1250" dirty="0">
                 <a:solidFill>
-                  <a:srgbClr val="94A3B8"/>
+                  <a:srgbClr val="304152"/>
                 </a:solidFill>
               </a:rPr>
               <a:t>Scan rapide sur mobile</a:t>
@@ -4860,13 +4848,13 @@
             </a:avLst>
           </a:prstGeom>
           <a:solidFill>
-            <a:srgbClr val="172033">
+            <a:srgbClr val="FFFFFF">
               <a:alpha val="96000"/>
             </a:srgbClr>
           </a:solidFill>
-          <a:ln w="14605">
+          <a:ln w="12700">
             <a:solidFill>
-              <a:srgbClr val="F59E0B"/>
+              <a:srgbClr val="D3E2EC"/>
             </a:solidFill>
             <a:prstDash val="solid"/>
           </a:ln>
@@ -4908,7 +4896,7 @@
             <a:r>
               <a:rPr lang="en-US" sz="1700" b="1" dirty="0">
                 <a:solidFill>
-                  <a:srgbClr val="FFFFFF"/>
+                  <a:srgbClr val="0F4272"/>
                 </a:solidFill>
               </a:rPr>
               <a:t>Fiche de progression</a:t>
@@ -4946,7 +4934,7 @@
             <a:r>
               <a:rPr lang="en-US" sz="1250" dirty="0">
                 <a:solidFill>
-                  <a:srgbClr val="94A3B8"/>
+                  <a:srgbClr val="304152"/>
                 </a:solidFill>
               </a:rPr>
               <a:t>Séance et contenu réalisé</a:t>
@@ -4972,13 +4960,13 @@
             </a:avLst>
           </a:prstGeom>
           <a:solidFill>
-            <a:srgbClr val="172033">
+            <a:srgbClr val="FFFFFF">
               <a:alpha val="96000"/>
             </a:srgbClr>
           </a:solidFill>
-          <a:ln w="14605">
+          <a:ln w="12700">
             <a:solidFill>
-              <a:srgbClr val="8B5CF6"/>
+              <a:srgbClr val="D3E2EC"/>
             </a:solidFill>
             <a:prstDash val="solid"/>
           </a:ln>
@@ -5049,7 +5037,7 @@
             <a:r>
               <a:rPr lang="en-US" sz="1700" b="1" dirty="0">
                 <a:solidFill>
-                  <a:srgbClr val="FFFFFF"/>
+                  <a:srgbClr val="0F4272"/>
                 </a:solidFill>
               </a:rPr>
               <a:t>Honoraires</a:t>
@@ -5087,7 +5075,7 @@
             <a:r>
               <a:rPr lang="en-US" sz="1250" dirty="0">
                 <a:solidFill>
-                  <a:srgbClr val="94A3B8"/>
+                  <a:srgbClr val="304152"/>
                 </a:solidFill>
               </a:rPr>
               <a:t>Calcul automatique à partir des séances émargées</a:t>
@@ -5261,7 +5249,7 @@
             <a:r>
               <a:rPr sz="1100" b="1">
                 <a:solidFill>
-                  <a:srgbClr val="0F4272"/>
+                  <a:srgbClr val="304152"/>
                 </a:solidFill>
                 <a:latin typeface="Aptos"/>
               </a:rPr>
@@ -5296,7 +5284,7 @@
             <a:r>
               <a:rPr sz="900" b="0">
                 <a:solidFill>
-                  <a:srgbClr val="657A8C"/>
+                  <a:srgbClr val="304152"/>
                 </a:solidFill>
                 <a:latin typeface="Aptos"/>
               </a:rPr>
@@ -5480,16 +5468,12 @@
             <a:avLst/>
           </a:prstGeom>
           <a:solidFill>
-            <a:srgbClr val="0B1121">
+            <a:srgbClr val="F8FAFC">
               <a:alpha val="93000"/>
             </a:srgbClr>
           </a:solidFill>
           <a:ln w="12700">
-            <a:solidFill>
-              <a:srgbClr val="0B1121">
-                <a:alpha val="0"/>
-              </a:srgbClr>
-            </a:solidFill>
+            <a:noFill/>
             <a:prstDash val="solid"/>
           </a:ln>
         </p:spPr>
@@ -5530,7 +5514,7 @@
             <a:r>
               <a:rPr lang="en-US" sz="2900" b="1" dirty="0">
                 <a:solidFill>
-                  <a:srgbClr val="FFFFFF"/>
+                  <a:srgbClr val="0F4272"/>
                 </a:solidFill>
               </a:rPr>
               <a:t>Fonctionnement du système</a:t>
@@ -5645,12 +5629,10 @@
             <a:avLst/>
           </a:prstGeom>
           <a:solidFill>
-            <a:srgbClr val="334155"/>
+            <a:srgbClr val="CBD5E1"/>
           </a:solidFill>
           <a:ln w="12700">
-            <a:solidFill>
-              <a:srgbClr val="334155"/>
-            </a:solidFill>
+            <a:noFill/>
             <a:prstDash val="solid"/>
           </a:ln>
         </p:spPr>
@@ -5689,7 +5671,7 @@
             <a:r>
               <a:rPr lang="en-US" sz="1600" dirty="0">
                 <a:solidFill>
-                  <a:srgbClr val="94A3B8"/>
+                  <a:srgbClr val="5A6E80"/>
                 </a:solidFill>
               </a:rPr>
               <a:t>EduTrack — Projet de Licence 3</a:t>
@@ -5725,7 +5707,7 @@
             <a:r>
               <a:rPr lang="en-US" sz="1600" b="1" dirty="0">
                 <a:solidFill>
-                  <a:srgbClr val="06B6D4"/>
+                  <a:srgbClr val="5A6E80"/>
                 </a:solidFill>
               </a:rPr>
               <a:t>4 / 9</a:t>
@@ -5751,13 +5733,13 @@
             </a:avLst>
           </a:prstGeom>
           <a:solidFill>
-            <a:srgbClr val="172033">
+            <a:srgbClr val="FFFFFF">
               <a:alpha val="96000"/>
             </a:srgbClr>
           </a:solidFill>
-          <a:ln w="17145">
+          <a:ln w="12700">
             <a:solidFill>
-              <a:srgbClr val="3B82F6"/>
+              <a:srgbClr val="D3E2EC"/>
             </a:solidFill>
             <a:prstDash val="solid"/>
           </a:ln>
@@ -5833,7 +5815,7 @@
             <a:r>
               <a:rPr lang="en-US" sz="1400" b="1" dirty="0">
                 <a:solidFill>
-                  <a:srgbClr val="3B82F6"/>
+                  <a:srgbClr val="304152"/>
                 </a:solidFill>
               </a:rPr>
               <a:t>1</a:t>
@@ -5871,7 +5853,7 @@
             <a:r>
               <a:rPr lang="en-US" sz="1700" b="1" dirty="0">
                 <a:solidFill>
-                  <a:srgbClr val="FFFFFF"/>
+                  <a:srgbClr val="0F4272"/>
                 </a:solidFill>
               </a:rPr>
               <a:t>Planifier</a:t>
@@ -5909,7 +5891,7 @@
             <a:r>
               <a:rPr lang="en-US" sz="1220" dirty="0">
                 <a:solidFill>
-                  <a:srgbClr val="94A3B8"/>
+                  <a:srgbClr val="0F4272"/>
                 </a:solidFill>
               </a:rPr>
               <a:t>Créer la séance</a:t>
@@ -5971,13 +5953,13 @@
             </a:avLst>
           </a:prstGeom>
           <a:solidFill>
-            <a:srgbClr val="172033">
+            <a:srgbClr val="FFFFFF">
               <a:alpha val="96000"/>
             </a:srgbClr>
           </a:solidFill>
-          <a:ln w="17145">
+          <a:ln w="12700">
             <a:solidFill>
-              <a:srgbClr val="06B6D4"/>
+              <a:srgbClr val="D3E2EC"/>
             </a:solidFill>
             <a:prstDash val="solid"/>
           </a:ln>
@@ -6053,7 +6035,7 @@
             <a:r>
               <a:rPr lang="en-US" sz="1400" b="1" dirty="0">
                 <a:solidFill>
-                  <a:srgbClr val="06B6D4"/>
+                  <a:srgbClr val="304152"/>
                 </a:solidFill>
               </a:rPr>
               <a:t>2</a:t>
@@ -6091,7 +6073,7 @@
             <a:r>
               <a:rPr lang="en-US" sz="1700" b="1" dirty="0">
                 <a:solidFill>
-                  <a:srgbClr val="FFFFFF"/>
+                  <a:srgbClr val="0F4272"/>
                 </a:solidFill>
               </a:rPr>
               <a:t>QR Code</a:t>
@@ -6129,7 +6111,7 @@
             <a:r>
               <a:rPr lang="en-US" sz="1220" dirty="0">
                 <a:solidFill>
-                  <a:srgbClr val="94A3B8"/>
+                  <a:srgbClr val="0F4272"/>
                 </a:solidFill>
               </a:rPr>
               <a:t>Identifiant unique</a:t>
@@ -6191,13 +6173,13 @@
             </a:avLst>
           </a:prstGeom>
           <a:solidFill>
-            <a:srgbClr val="172033">
+            <a:srgbClr val="FFFFFF">
               <a:alpha val="96000"/>
             </a:srgbClr>
           </a:solidFill>
-          <a:ln w="17145">
+          <a:ln w="12700">
             <a:solidFill>
-              <a:srgbClr val="10B981"/>
+              <a:srgbClr val="D3E2EC"/>
             </a:solidFill>
             <a:prstDash val="solid"/>
           </a:ln>
@@ -6302,7 +6284,7 @@
             <a:r>
               <a:rPr lang="en-US" sz="1400" b="1" dirty="0">
                 <a:solidFill>
-                  <a:srgbClr val="10B981"/>
+                  <a:srgbClr val="304152"/>
                 </a:solidFill>
               </a:rPr>
               <a:t>3</a:t>
@@ -6340,7 +6322,7 @@
             <a:r>
               <a:rPr lang="en-US" sz="1700" b="1" dirty="0">
                 <a:solidFill>
-                  <a:srgbClr val="FFFFFF"/>
+                  <a:srgbClr val="0F4272"/>
                 </a:solidFill>
               </a:rPr>
               <a:t>Scanner</a:t>
@@ -6378,7 +6360,7 @@
             <a:r>
               <a:rPr lang="en-US" sz="1220" dirty="0">
                 <a:solidFill>
-                  <a:srgbClr val="94A3B8"/>
+                  <a:srgbClr val="0F4272"/>
                 </a:solidFill>
               </a:rPr>
               <a:t>Action mobile</a:t>
@@ -6440,13 +6422,13 @@
             </a:avLst>
           </a:prstGeom>
           <a:solidFill>
-            <a:srgbClr val="172033">
+            <a:srgbClr val="FFFFFF">
               <a:alpha val="96000"/>
             </a:srgbClr>
           </a:solidFill>
-          <a:ln w="17145">
+          <a:ln w="12700">
             <a:solidFill>
-              <a:srgbClr val="F59E0B"/>
+              <a:srgbClr val="D3E2EC"/>
             </a:solidFill>
             <a:prstDash val="solid"/>
           </a:ln>
@@ -6522,7 +6504,7 @@
             <a:r>
               <a:rPr lang="en-US" sz="1400" b="1" dirty="0">
                 <a:solidFill>
-                  <a:srgbClr val="F59E0B"/>
+                  <a:srgbClr val="304152"/>
                 </a:solidFill>
               </a:rPr>
               <a:t>4</a:t>
@@ -6560,7 +6542,7 @@
             <a:r>
               <a:rPr lang="en-US" sz="1700" b="1" dirty="0">
                 <a:solidFill>
-                  <a:srgbClr val="FFFFFF"/>
+                  <a:srgbClr val="0F4272"/>
                 </a:solidFill>
               </a:rPr>
               <a:t>Enregistrer automatiquement</a:t>
@@ -6598,7 +6580,7 @@
             <a:r>
               <a:rPr lang="en-US" sz="1220" dirty="0">
                 <a:solidFill>
-                  <a:srgbClr val="94A3B8"/>
+                  <a:srgbClr val="0F4272"/>
                 </a:solidFill>
               </a:rPr>
               <a:t>Émargement tracé</a:t>
@@ -6660,13 +6642,13 @@
             </a:avLst>
           </a:prstGeom>
           <a:solidFill>
-            <a:srgbClr val="172033">
+            <a:srgbClr val="FFFFFF">
               <a:alpha val="96000"/>
             </a:srgbClr>
           </a:solidFill>
-          <a:ln w="17145">
+          <a:ln w="12700">
             <a:solidFill>
-              <a:srgbClr val="8B5CF6"/>
+              <a:srgbClr val="D3E2EC"/>
             </a:solidFill>
             <a:prstDash val="solid"/>
           </a:ln>
@@ -6771,7 +6753,7 @@
             <a:r>
               <a:rPr lang="en-US" sz="1400" b="1" dirty="0">
                 <a:solidFill>
-                  <a:srgbClr val="8B5CF6"/>
+                  <a:srgbClr val="304152"/>
                 </a:solidFill>
               </a:rPr>
               <a:t>5</a:t>
@@ -6809,7 +6791,7 @@
             <a:r>
               <a:rPr lang="en-US" sz="1700" b="1" dirty="0">
                 <a:solidFill>
-                  <a:srgbClr val="FFFFFF"/>
+                  <a:srgbClr val="0F4272"/>
                 </a:solidFill>
               </a:rPr>
               <a:t>Calculer</a:t>
@@ -6847,50 +6829,12 @@
             <a:r>
               <a:rPr lang="en-US" sz="1220" dirty="0">
                 <a:solidFill>
-                  <a:srgbClr val="94A3B8"/>
+                  <a:srgbClr val="0F4272"/>
                 </a:solidFill>
               </a:rPr>
               <a:t>Honoraires</a:t>
             </a:r>
             <a:endParaRPr lang="en-US" sz="1220" dirty="0"/>
-          </a:p>
-        </p:txBody>
-      </p:sp>
-      <p:sp>
-        <p:nvSpPr>
-          <p:cNvPr id="46" name="Text 38"/>
-          <p:cNvSpPr/>
-          <p:nvPr/>
-        </p:nvSpPr>
-        <p:spPr>
-          <a:xfrm>
-            <a:off x="1920240" y="5532120"/>
-            <a:ext cx="8321040" cy="256032"/>
-          </a:xfrm>
-          <a:prstGeom prst="rect">
-            <a:avLst/>
-          </a:prstGeom>
-          <a:noFill/>
-          <a:ln/>
-        </p:spPr>
-        <p:txBody>
-          <a:bodyPr wrap="square" lIns="0" tIns="0" rIns="0" bIns="0" rtlCol="0" anchor="ctr">
-            <a:normAutofit/>
-          </a:bodyPr>
-          <a:lstStyle/>
-          <a:p>
-            <a:pPr marL="0" indent="0" algn="ctr">
-              <a:buNone/>
-            </a:pPr>
-            <a:r>
-              <a:rPr lang="en-US" sz="1500" i="1" dirty="0">
-                <a:solidFill>
-                  <a:srgbClr val="94A3B8"/>
-                </a:solidFill>
-              </a:rPr>
-              <a:t>Le public écoute le scénario pendant que la slide montre uniquement le flux.</a:t>
-            </a:r>
-            <a:endParaRPr lang="en-US" sz="1500" dirty="0"/>
           </a:p>
         </p:txBody>
       </p:sp>
@@ -7035,7 +6979,7 @@
             <a:r>
               <a:rPr sz="1100" b="1">
                 <a:solidFill>
-                  <a:srgbClr val="0F4272"/>
+                  <a:srgbClr val="304152"/>
                 </a:solidFill>
                 <a:latin typeface="Aptos"/>
               </a:rPr>
@@ -7070,7 +7014,7 @@
             <a:r>
               <a:rPr sz="900" b="0">
                 <a:solidFill>
-                  <a:srgbClr val="657A8C"/>
+                  <a:srgbClr val="304152"/>
                 </a:solidFill>
                 <a:latin typeface="Aptos"/>
               </a:rPr>
@@ -7179,7 +7123,7 @@
             <a:avLst/>
           </a:prstGeom>
           <a:solidFill>
-            <a:srgbClr val="070D1F"/>
+            <a:srgbClr val="F8FAFC"/>
           </a:solidFill>
           <a:ln w="12700" cap="flat" cmpd="sng" algn="ctr">
             <a:noFill/>
@@ -7234,7 +7178,7 @@
             <a:avLst/>
           </a:prstGeom>
           <a:solidFill>
-            <a:srgbClr val="0C1834">
+            <a:srgbClr val="F8FAFC">
               <a:alpha val="55000"/>
             </a:srgbClr>
           </a:solidFill>
@@ -7291,7 +7235,7 @@
             <a:avLst/>
           </a:prstGeom>
           <a:solidFill>
-            <a:srgbClr val="0F172A">
+            <a:srgbClr val="F8FAFC">
               <a:alpha val="28000"/>
             </a:srgbClr>
           </a:solidFill>
@@ -7358,7 +7302,7 @@
             <a:r>
               <a:rPr lang="fr-FR" sz="2900" b="1" dirty="0">
                 <a:solidFill>
-                  <a:srgbClr val="FFFFFF"/>
+                  <a:srgbClr val="0F4272"/>
                 </a:solidFill>
                 <a:latin typeface="Aptos" panose="020B0004020202020204" pitchFamily="34" charset="0"/>
               </a:rPr>
@@ -7494,7 +7438,7 @@
             <a:r>
               <a:rPr lang="fr-FR" sz="1000">
                 <a:solidFill>
-                  <a:srgbClr val="94A3B8"/>
+                  <a:srgbClr val="304152"/>
                 </a:solidFill>
                 <a:latin typeface="Aptos" panose="020B0004020202020204" pitchFamily="34" charset="0"/>
               </a:rPr>
@@ -7535,7 +7479,7 @@
             <a:r>
               <a:rPr lang="fr-FR" sz="1000" b="1">
                 <a:solidFill>
-                  <a:srgbClr val="00BCD4"/>
+                  <a:srgbClr val="304152"/>
                 </a:solidFill>
                 <a:latin typeface="Aptos" panose="020B0004020202020204" pitchFamily="34" charset="0"/>
               </a:rPr>
@@ -7605,7 +7549,7 @@
             <a:r>
               <a:rPr lang="fr-FR" sz="1300">
                 <a:solidFill>
-                  <a:srgbClr val="94A3B8"/>
+                  <a:srgbClr val="304152"/>
                 </a:solidFill>
                 <a:latin typeface="Aptos" panose="020B0004020202020204" pitchFamily="34" charset="0"/>
               </a:rPr>
@@ -7635,13 +7579,13 @@
             <a:avLst/>
           </a:prstGeom>
           <a:solidFill>
-            <a:srgbClr val="131D31">
+            <a:srgbClr val="FFFFFF">
               <a:alpha val="96000"/>
             </a:srgbClr>
           </a:solidFill>
-          <a:ln w="17145">
+          <a:ln w="12700">
             <a:solidFill>
-              <a:srgbClr val="00BCD4"/>
+              <a:srgbClr val="D3E2EC"/>
             </a:solidFill>
           </a:ln>
         </p:spPr>
@@ -7702,7 +7646,7 @@
             <a:r>
               <a:rPr lang="fr-FR" sz="1200" b="1">
                 <a:solidFill>
-                  <a:srgbClr val="00BCD4"/>
+                  <a:srgbClr val="304152"/>
                 </a:solidFill>
                 <a:latin typeface="Aptos" panose="020B0004020202020204" pitchFamily="34" charset="0"/>
               </a:rPr>
@@ -7787,7 +7731,7 @@
             <a:avLst/>
           </a:prstGeom>
           <a:solidFill>
-            <a:srgbClr val="1E293B"/>
+            <a:srgbClr val="E8F5FD"/>
           </a:solidFill>
           <a:ln w="12700" cap="flat" cmpd="sng" algn="ctr">
             <a:noFill/>
@@ -7853,7 +7797,7 @@
             <a:r>
               <a:rPr lang="fr-FR" sz="900" b="1">
                 <a:solidFill>
-                  <a:srgbClr val="FFFFFF"/>
+                  <a:srgbClr val="304152"/>
                 </a:solidFill>
                 <a:latin typeface="Aptos" panose="020B0004020202020204" pitchFamily="34" charset="0"/>
               </a:rPr>
@@ -7883,13 +7827,13 @@
             <a:avLst/>
           </a:prstGeom>
           <a:solidFill>
-            <a:srgbClr val="131D31">
+            <a:srgbClr val="FFFFFF">
               <a:alpha val="96000"/>
             </a:srgbClr>
           </a:solidFill>
-          <a:ln w="17145">
+          <a:ln w="12700">
             <a:solidFill>
-              <a:srgbClr val="00BCD4"/>
+              <a:srgbClr val="D3E2EC"/>
             </a:solidFill>
           </a:ln>
         </p:spPr>
@@ -7950,7 +7894,7 @@
             <a:r>
               <a:rPr lang="fr-FR" sz="1700" b="1">
                 <a:solidFill>
-                  <a:srgbClr val="00BCD4"/>
+                  <a:srgbClr val="0F4272"/>
                 </a:solidFill>
                 <a:latin typeface="Aptos" panose="020B0004020202020204" pitchFamily="34" charset="0"/>
               </a:rPr>
@@ -7991,7 +7935,7 @@
             <a:r>
               <a:rPr lang="fr-FR" sz="1000">
                 <a:solidFill>
-                  <a:srgbClr val="94A3B8"/>
+                  <a:srgbClr val="304152"/>
                 </a:solidFill>
                 <a:latin typeface="Aptos" panose="020B0004020202020204" pitchFamily="34" charset="0"/>
               </a:rPr>
@@ -8021,12 +7965,10 @@
             <a:avLst/>
           </a:prstGeom>
           <a:solidFill>
-            <a:srgbClr val="0F172A"/>
+            <a:srgbClr val="F8FAFC"/>
           </a:solidFill>
           <a:ln w="15240">
-            <a:solidFill>
-              <a:srgbClr val="00BCD4"/>
-            </a:solidFill>
+            <a:noFill/>
           </a:ln>
         </p:spPr>
         <p:style>
@@ -8301,7 +8243,7 @@
             <a:avLst/>
           </a:prstGeom>
           <a:solidFill>
-            <a:srgbClr val="1E293B"/>
+            <a:srgbClr val="E8F5FD"/>
           </a:solidFill>
           <a:ln w="12700" cap="flat" cmpd="sng" algn="ctr">
             <a:noFill/>
@@ -8356,7 +8298,7 @@
             <a:avLst/>
           </a:prstGeom>
           <a:solidFill>
-            <a:srgbClr val="1E293B"/>
+            <a:srgbClr val="E8F5FD"/>
           </a:solidFill>
           <a:ln w="12700" cap="flat" cmpd="sng" algn="ctr">
             <a:noFill/>
@@ -8411,7 +8353,7 @@
             <a:avLst/>
           </a:prstGeom>
           <a:solidFill>
-            <a:srgbClr val="1E293B"/>
+            <a:srgbClr val="E8F5FD"/>
           </a:solidFill>
           <a:ln w="12700" cap="flat" cmpd="sng" algn="ctr">
             <a:noFill/>
@@ -8694,12 +8636,10 @@
             <a:avLst/>
           </a:prstGeom>
           <a:solidFill>
-            <a:srgbClr val="020617"/>
+            <a:srgbClr val="CBD5E1"/>
           </a:solidFill>
           <a:ln w="15240">
-            <a:solidFill>
-              <a:srgbClr val="475569"/>
-            </a:solidFill>
+            <a:noFill/>
           </a:ln>
         </p:spPr>
         <p:style>
@@ -8748,7 +8688,7 @@
             <a:avLst/>
           </a:prstGeom>
           <a:solidFill>
-            <a:srgbClr val="0F172A"/>
+            <a:srgbClr val="F8FAFC"/>
           </a:solidFill>
           <a:ln w="12700" cap="flat" cmpd="sng" algn="ctr">
             <a:noFill/>
@@ -8858,7 +8798,7 @@
             <a:avLst/>
           </a:prstGeom>
           <a:solidFill>
-            <a:srgbClr val="334155"/>
+            <a:srgbClr val="CBD5E1"/>
           </a:solidFill>
           <a:ln w="12700" cap="flat" cmpd="sng" algn="ctr">
             <a:noFill/>
@@ -8913,7 +8853,7 @@
             <a:avLst/>
           </a:prstGeom>
           <a:solidFill>
-            <a:srgbClr val="334155"/>
+            <a:srgbClr val="CBD5E1"/>
           </a:solidFill>
           <a:ln w="12700" cap="flat" cmpd="sng" algn="ctr">
             <a:noFill/>
@@ -8968,7 +8908,7 @@
             <a:avLst/>
           </a:prstGeom>
           <a:solidFill>
-            <a:srgbClr val="334155"/>
+            <a:srgbClr val="CBD5E1"/>
           </a:solidFill>
           <a:ln w="12700" cap="flat" cmpd="sng" algn="ctr">
             <a:noFill/>
@@ -9023,7 +8963,7 @@
             <a:avLst/>
           </a:prstGeom>
           <a:solidFill>
-            <a:srgbClr val="334155"/>
+            <a:srgbClr val="CBD5E1"/>
           </a:solidFill>
           <a:ln w="12700" cap="flat" cmpd="sng" algn="ctr">
             <a:noFill/>
@@ -9273,7 +9213,7 @@
             <a:r>
               <a:rPr lang="fr-FR" sz="900" b="1">
                 <a:solidFill>
-                  <a:srgbClr val="FFFFFF"/>
+                  <a:srgbClr val="304152"/>
                 </a:solidFill>
                 <a:latin typeface="Aptos" panose="020B0004020202020204" pitchFamily="34" charset="0"/>
               </a:rPr>
@@ -9303,13 +9243,13 @@
             <a:avLst/>
           </a:prstGeom>
           <a:solidFill>
-            <a:srgbClr val="131D31">
+            <a:srgbClr val="FFFFFF">
               <a:alpha val="96000"/>
             </a:srgbClr>
           </a:solidFill>
-          <a:ln w="17145">
+          <a:ln w="12700">
             <a:solidFill>
-              <a:srgbClr val="10B981"/>
+              <a:srgbClr val="D3E2EC"/>
             </a:solidFill>
           </a:ln>
         </p:spPr>
@@ -9370,7 +9310,7 @@
             <a:r>
               <a:rPr lang="fr-FR" sz="1700" b="1">
                 <a:solidFill>
-                  <a:srgbClr val="10B981"/>
+                  <a:srgbClr val="0F4272"/>
                 </a:solidFill>
                 <a:latin typeface="Aptos" panose="020B0004020202020204" pitchFamily="34" charset="0"/>
               </a:rPr>
@@ -9411,7 +9351,7 @@
             <a:r>
               <a:rPr lang="fr-FR" sz="1000">
                 <a:solidFill>
-                  <a:srgbClr val="94A3B8"/>
+                  <a:srgbClr val="304152"/>
                 </a:solidFill>
                 <a:latin typeface="Aptos" panose="020B0004020202020204" pitchFamily="34" charset="0"/>
               </a:rPr>
@@ -9545,7 +9485,7 @@
             <a:r>
               <a:rPr lang="fr-FR" sz="900" b="1" dirty="0">
                 <a:solidFill>
-                  <a:srgbClr val="FFFFFF"/>
+                  <a:srgbClr val="304152"/>
                 </a:solidFill>
                 <a:latin typeface="Aptos" panose="020B0004020202020204" pitchFamily="34" charset="0"/>
               </a:rPr>
@@ -9643,7 +9583,7 @@
             <a:r>
               <a:rPr lang="fr-FR" sz="900" b="1">
                 <a:solidFill>
-                  <a:srgbClr val="FFFFFF"/>
+                  <a:srgbClr val="304152"/>
                 </a:solidFill>
                 <a:latin typeface="Aptos" panose="020B0004020202020204" pitchFamily="34" charset="0"/>
               </a:rPr>
@@ -9673,13 +9613,13 @@
             <a:avLst/>
           </a:prstGeom>
           <a:solidFill>
-            <a:srgbClr val="131D31">
+            <a:srgbClr val="FFFFFF">
               <a:alpha val="96000"/>
             </a:srgbClr>
           </a:solidFill>
-          <a:ln w="17145">
+          <a:ln w="12700">
             <a:solidFill>
-              <a:srgbClr val="F59E0B"/>
+              <a:srgbClr val="D3E2EC"/>
             </a:solidFill>
           </a:ln>
         </p:spPr>
@@ -9740,7 +9680,7 @@
             <a:r>
               <a:rPr lang="fr-FR" sz="1700" b="1">
                 <a:solidFill>
-                  <a:srgbClr val="F59E0B"/>
+                  <a:srgbClr val="0F4272"/>
                 </a:solidFill>
                 <a:latin typeface="Aptos" panose="020B0004020202020204" pitchFamily="34" charset="0"/>
               </a:rPr>
@@ -9781,7 +9721,7 @@
             <a:r>
               <a:rPr lang="fr-FR" sz="1000">
                 <a:solidFill>
-                  <a:srgbClr val="94A3B8"/>
+                  <a:srgbClr val="304152"/>
                 </a:solidFill>
                 <a:latin typeface="Aptos" panose="020B0004020202020204" pitchFamily="34" charset="0"/>
               </a:rPr>
@@ -9915,7 +9855,7 @@
             <a:r>
               <a:rPr lang="fr-FR" sz="900" b="1">
                 <a:solidFill>
-                  <a:srgbClr val="FFFFFF"/>
+                  <a:srgbClr val="304152"/>
                 </a:solidFill>
                 <a:latin typeface="Aptos" panose="020B0004020202020204" pitchFamily="34" charset="0"/>
               </a:rPr>
@@ -9956,7 +9896,7 @@
             <a:r>
               <a:rPr lang="fr-FR" sz="800">
                 <a:solidFill>
-                  <a:srgbClr val="CBD5E1"/>
+                  <a:srgbClr val="0F4272"/>
                 </a:solidFill>
                 <a:latin typeface="Aptos" panose="020B0004020202020204" pitchFamily="34" charset="0"/>
               </a:rPr>
@@ -10165,7 +10105,7 @@
             <a:r>
               <a:rPr lang="fr-FR" sz="800">
                 <a:solidFill>
-                  <a:srgbClr val="94A3B8"/>
+                  <a:srgbClr val="304152"/>
                 </a:solidFill>
                 <a:latin typeface="Aptos" panose="020B0004020202020204" pitchFamily="34" charset="0"/>
               </a:rPr>
@@ -10206,7 +10146,7 @@
             <a:r>
               <a:rPr lang="fr-FR" sz="1200" b="1">
                 <a:solidFill>
-                  <a:srgbClr val="F59E0B"/>
+                  <a:srgbClr val="304152"/>
                 </a:solidFill>
                 <a:latin typeface="Aptos" panose="020B0004020202020204" pitchFamily="34" charset="0"/>
               </a:rPr>
@@ -10284,7 +10224,7 @@
             <a:r>
               <a:rPr sz="1100" b="1">
                 <a:solidFill>
-                  <a:srgbClr val="0F4272"/>
+                  <a:srgbClr val="304152"/>
                 </a:solidFill>
                 <a:latin typeface="Aptos"/>
               </a:rPr>
@@ -10319,7 +10259,7 @@
             <a:r>
               <a:rPr sz="900" b="0">
                 <a:solidFill>
-                  <a:srgbClr val="657A8C"/>
+                  <a:srgbClr val="304152"/>
                 </a:solidFill>
                 <a:latin typeface="Aptos"/>
               </a:rPr>
@@ -10494,16 +10434,12 @@
             <a:avLst/>
           </a:prstGeom>
           <a:solidFill>
-            <a:srgbClr val="0B1121">
+            <a:srgbClr val="F8FAFC">
               <a:alpha val="93000"/>
             </a:srgbClr>
           </a:solidFill>
           <a:ln w="12700">
-            <a:solidFill>
-              <a:srgbClr val="0B1121">
-                <a:alpha val="0"/>
-              </a:srgbClr>
-            </a:solidFill>
+            <a:noFill/>
             <a:prstDash val="solid"/>
           </a:ln>
         </p:spPr>
@@ -10544,7 +10480,7 @@
             <a:r>
               <a:rPr lang="en-US" sz="2900" b="1" dirty="0">
                 <a:solidFill>
-                  <a:srgbClr val="FFFFFF"/>
+                  <a:srgbClr val="0F4272"/>
                 </a:solidFill>
               </a:rPr>
               <a:t>Technologies &amp; </a:t>
@@ -10552,7 +10488,7 @@
             <a:r>
               <a:rPr lang="en-US" sz="2900" b="1" dirty="0" err="1">
                 <a:solidFill>
-                  <a:srgbClr val="FFFFFF"/>
+                  <a:srgbClr val="0F4272"/>
                 </a:solidFill>
               </a:rPr>
               <a:t>Outils</a:t>
@@ -10560,7 +10496,7 @@
             <a:r>
               <a:rPr lang="en-US" sz="2900" b="1" dirty="0">
                 <a:solidFill>
-                  <a:srgbClr val="FFFFFF"/>
+                  <a:srgbClr val="0F4272"/>
                 </a:solidFill>
               </a:rPr>
               <a:t> </a:t>
@@ -10568,7 +10504,7 @@
             <a:r>
               <a:rPr lang="en-US" sz="2900" b="1" dirty="0" err="1">
                 <a:solidFill>
-                  <a:srgbClr val="FFFFFF"/>
+                  <a:srgbClr val="0F4272"/>
                 </a:solidFill>
               </a:rPr>
               <a:t>utilisés</a:t>
@@ -10683,12 +10619,10 @@
             <a:avLst/>
           </a:prstGeom>
           <a:solidFill>
-            <a:srgbClr val="334155"/>
+            <a:srgbClr val="CBD5E1"/>
           </a:solidFill>
           <a:ln w="12700">
-            <a:solidFill>
-              <a:srgbClr val="334155"/>
-            </a:solidFill>
+            <a:noFill/>
             <a:prstDash val="solid"/>
           </a:ln>
         </p:spPr>
@@ -10727,7 +10661,7 @@
             <a:r>
               <a:rPr lang="en-US" sz="1600" dirty="0">
                 <a:solidFill>
-                  <a:srgbClr val="94A3B8"/>
+                  <a:srgbClr val="5A6E80"/>
                 </a:solidFill>
               </a:rPr>
               <a:t>EduTrack — Projet de Licence 3</a:t>
@@ -10763,7 +10697,7 @@
             <a:r>
               <a:rPr lang="en-US" sz="1600" b="1" dirty="0">
                 <a:solidFill>
-                  <a:srgbClr val="06B6D4"/>
+                  <a:srgbClr val="5A6E80"/>
                 </a:solidFill>
               </a:rPr>
               <a:t>6 / 9</a:t>
@@ -10789,13 +10723,13 @@
             </a:avLst>
           </a:prstGeom>
           <a:solidFill>
-            <a:srgbClr val="172033">
+            <a:srgbClr val="FFFFFF">
               <a:alpha val="92000"/>
             </a:srgbClr>
           </a:solidFill>
-          <a:ln w="19050">
+          <a:ln w="12700">
             <a:solidFill>
-              <a:srgbClr val="10B981">
+              <a:srgbClr val="D3E2EC">
                 <a:alpha val="70000"/>
               </a:srgbClr>
             </a:solidFill>
@@ -10837,7 +10771,7 @@
             <a:r>
               <a:rPr lang="en-US" sz="1600" b="1" dirty="0">
                 <a:solidFill>
-                  <a:srgbClr val="10B981"/>
+                  <a:srgbClr val="0F4272"/>
                 </a:solidFill>
               </a:rPr>
               <a:t>BACKEND</a:t>
@@ -10863,13 +10797,13 @@
             </a:avLst>
           </a:prstGeom>
           <a:solidFill>
-            <a:srgbClr val="172033">
+            <a:srgbClr val="FFFFFF">
               <a:alpha val="96000"/>
             </a:srgbClr>
           </a:solidFill>
           <a:ln w="12700">
             <a:solidFill>
-              <a:srgbClr val="334155"/>
+              <a:srgbClr val="D3E2EC"/>
             </a:solidFill>
             <a:prstDash val="solid"/>
           </a:ln>
@@ -10940,7 +10874,7 @@
             <a:r>
               <a:rPr lang="en-US" sz="1400" b="1" dirty="0">
                 <a:solidFill>
-                  <a:srgbClr val="FFFFFF"/>
+                  <a:srgbClr val="304152"/>
                 </a:solidFill>
               </a:rPr>
               <a:t>Spring Boot</a:t>
@@ -10966,13 +10900,13 @@
             </a:avLst>
           </a:prstGeom>
           <a:solidFill>
-            <a:srgbClr val="172033">
+            <a:srgbClr val="FFFFFF">
               <a:alpha val="96000"/>
             </a:srgbClr>
           </a:solidFill>
           <a:ln w="12700">
             <a:solidFill>
-              <a:srgbClr val="334155"/>
+              <a:srgbClr val="D3E2EC"/>
             </a:solidFill>
             <a:prstDash val="solid"/>
           </a:ln>
@@ -11043,7 +10977,7 @@
             <a:r>
               <a:rPr lang="en-US" sz="1400" b="1" dirty="0">
                 <a:solidFill>
-                  <a:srgbClr val="FFFFFF"/>
+                  <a:srgbClr val="304152"/>
                 </a:solidFill>
               </a:rPr>
               <a:t>Java 17</a:t>
@@ -11069,13 +11003,13 @@
             </a:avLst>
           </a:prstGeom>
           <a:solidFill>
-            <a:srgbClr val="172033">
+            <a:srgbClr val="FFFFFF">
               <a:alpha val="96000"/>
             </a:srgbClr>
           </a:solidFill>
           <a:ln w="12700">
             <a:solidFill>
-              <a:srgbClr val="334155"/>
+              <a:srgbClr val="D3E2EC"/>
             </a:solidFill>
             <a:prstDash val="solid"/>
           </a:ln>
@@ -11146,7 +11080,7 @@
             <a:r>
               <a:rPr lang="en-US" sz="1400" b="1" dirty="0">
                 <a:solidFill>
-                  <a:srgbClr val="FFFFFF"/>
+                  <a:srgbClr val="304152"/>
                 </a:solidFill>
               </a:rPr>
               <a:t>PostgreSQL</a:t>
@@ -11172,13 +11106,13 @@
             </a:avLst>
           </a:prstGeom>
           <a:solidFill>
-            <a:srgbClr val="172033">
+            <a:srgbClr val="FFFFFF">
               <a:alpha val="92000"/>
             </a:srgbClr>
           </a:solidFill>
-          <a:ln w="19050">
+          <a:ln w="12700">
             <a:solidFill>
-              <a:srgbClr val="06B6D4">
+              <a:srgbClr val="D3E2EC">
                 <a:alpha val="70000"/>
               </a:srgbClr>
             </a:solidFill>
@@ -11220,7 +11154,7 @@
             <a:r>
               <a:rPr lang="en-US" sz="1600" b="1" dirty="0">
                 <a:solidFill>
-                  <a:srgbClr val="06B6D4"/>
+                  <a:srgbClr val="0F4272"/>
                 </a:solidFill>
               </a:rPr>
               <a:t>FRONTEND ( WEB &amp; MOBILE )</a:t>
@@ -11246,13 +11180,13 @@
             </a:avLst>
           </a:prstGeom>
           <a:solidFill>
-            <a:srgbClr val="172033">
+            <a:srgbClr val="FFFFFF">
               <a:alpha val="96000"/>
             </a:srgbClr>
           </a:solidFill>
           <a:ln w="12700">
             <a:solidFill>
-              <a:srgbClr val="334155"/>
+              <a:srgbClr val="D3E2EC"/>
             </a:solidFill>
             <a:prstDash val="solid"/>
           </a:ln>
@@ -11323,7 +11257,7 @@
             <a:r>
               <a:rPr lang="en-US" sz="1400" b="1" dirty="0">
                 <a:solidFill>
-                  <a:srgbClr val="FFFFFF"/>
+                  <a:srgbClr val="304152"/>
                 </a:solidFill>
               </a:rPr>
               <a:t>Angular</a:t>
@@ -11349,13 +11283,13 @@
             </a:avLst>
           </a:prstGeom>
           <a:solidFill>
-            <a:srgbClr val="172033">
+            <a:srgbClr val="FFFFFF">
               <a:alpha val="96000"/>
             </a:srgbClr>
           </a:solidFill>
           <a:ln w="12700">
             <a:solidFill>
-              <a:srgbClr val="334155"/>
+              <a:srgbClr val="D3E2EC"/>
             </a:solidFill>
             <a:prstDash val="solid"/>
           </a:ln>
@@ -11426,7 +11360,7 @@
             <a:r>
               <a:rPr lang="en-US" sz="1400" b="1" dirty="0">
                 <a:solidFill>
-                  <a:srgbClr val="FFFFFF"/>
+                  <a:srgbClr val="304152"/>
                 </a:solidFill>
               </a:rPr>
               <a:t>Ionic</a:t>
@@ -11452,13 +11386,13 @@
             </a:avLst>
           </a:prstGeom>
           <a:solidFill>
-            <a:srgbClr val="172033">
+            <a:srgbClr val="FFFFFF">
               <a:alpha val="92000"/>
             </a:srgbClr>
           </a:solidFill>
-          <a:ln w="19050">
+          <a:ln w="12700">
             <a:solidFill>
-              <a:srgbClr val="F59E0B">
+              <a:srgbClr val="D3E2EC">
                 <a:alpha val="70000"/>
               </a:srgbClr>
             </a:solidFill>
@@ -11500,7 +11434,7 @@
             <a:r>
               <a:rPr lang="en-US" sz="1600" b="1" dirty="0">
                 <a:solidFill>
-                  <a:srgbClr val="F59E0B"/>
+                  <a:srgbClr val="0F4272"/>
                 </a:solidFill>
               </a:rPr>
               <a:t>OUTILS &amp; CONCEPTION</a:t>
@@ -11526,13 +11460,13 @@
             </a:avLst>
           </a:prstGeom>
           <a:solidFill>
-            <a:srgbClr val="172033">
+            <a:srgbClr val="FFFFFF">
               <a:alpha val="96000"/>
             </a:srgbClr>
           </a:solidFill>
           <a:ln w="12700">
             <a:solidFill>
-              <a:srgbClr val="334155"/>
+              <a:srgbClr val="D3E2EC"/>
             </a:solidFill>
             <a:prstDash val="solid"/>
           </a:ln>
@@ -11603,7 +11537,7 @@
             <a:r>
               <a:rPr lang="en-US" sz="1400" b="1" dirty="0">
                 <a:solidFill>
-                  <a:srgbClr val="FFFFFF"/>
+                  <a:srgbClr val="304152"/>
                 </a:solidFill>
               </a:rPr>
               <a:t>Git</a:t>
@@ -11629,13 +11563,13 @@
             </a:avLst>
           </a:prstGeom>
           <a:solidFill>
-            <a:srgbClr val="172033">
+            <a:srgbClr val="FFFFFF">
               <a:alpha val="96000"/>
             </a:srgbClr>
           </a:solidFill>
           <a:ln w="12700">
             <a:solidFill>
-              <a:srgbClr val="334155"/>
+              <a:srgbClr val="D3E2EC"/>
             </a:solidFill>
             <a:prstDash val="solid"/>
           </a:ln>
@@ -11706,7 +11640,7 @@
             <a:r>
               <a:rPr lang="en-US" sz="1400" b="1" dirty="0">
                 <a:solidFill>
-                  <a:srgbClr val="FFFFFF"/>
+                  <a:srgbClr val="304152"/>
                 </a:solidFill>
               </a:rPr>
               <a:t>GitHub</a:t>
@@ -11732,13 +11666,13 @@
             </a:avLst>
           </a:prstGeom>
           <a:solidFill>
-            <a:srgbClr val="172033">
+            <a:srgbClr val="FFFFFF">
               <a:alpha val="96000"/>
             </a:srgbClr>
           </a:solidFill>
           <a:ln w="12700">
             <a:solidFill>
-              <a:srgbClr val="334155"/>
+              <a:srgbClr val="D3E2EC"/>
             </a:solidFill>
             <a:prstDash val="solid"/>
           </a:ln>
@@ -11809,7 +11743,7 @@
             <a:r>
               <a:rPr lang="en-US" sz="1400" b="1" dirty="0">
                 <a:solidFill>
-                  <a:srgbClr val="FFFFFF"/>
+                  <a:srgbClr val="304152"/>
                 </a:solidFill>
               </a:rPr>
               <a:t>Swagger</a:t>
@@ -11835,13 +11769,13 @@
             </a:avLst>
           </a:prstGeom>
           <a:solidFill>
-            <a:srgbClr val="172033">
+            <a:srgbClr val="FFFFFF">
               <a:alpha val="96000"/>
             </a:srgbClr>
           </a:solidFill>
           <a:ln w="12700">
             <a:solidFill>
-              <a:srgbClr val="334155"/>
+              <a:srgbClr val="D3E2EC"/>
             </a:solidFill>
             <a:prstDash val="solid"/>
           </a:ln>
@@ -11912,7 +11846,7 @@
             <a:r>
               <a:rPr lang="en-US" sz="1400" b="1" dirty="0">
                 <a:solidFill>
-                  <a:srgbClr val="FFFFFF"/>
+                  <a:srgbClr val="304152"/>
                 </a:solidFill>
               </a:rPr>
               <a:t>UML</a:t>
@@ -11990,7 +11924,7 @@
             <a:r>
               <a:rPr sz="1100" b="1">
                 <a:solidFill>
-                  <a:srgbClr val="0F4272"/>
+                  <a:srgbClr val="304152"/>
                 </a:solidFill>
                 <a:latin typeface="Aptos"/>
               </a:rPr>
@@ -12025,7 +11959,7 @@
             <a:r>
               <a:rPr sz="900" b="0">
                 <a:solidFill>
-                  <a:srgbClr val="657A8C"/>
+                  <a:srgbClr val="304152"/>
                 </a:solidFill>
                 <a:latin typeface="Aptos"/>
               </a:rPr>
@@ -12143,7 +12077,7 @@
             <a:avLst/>
           </a:prstGeom>
           <a:solidFill>
-            <a:srgbClr val="070D1F"/>
+            <a:srgbClr val="F8FAFC"/>
           </a:solidFill>
           <a:ln w="12700" cap="flat" cmpd="sng" algn="ctr">
             <a:noFill/>
@@ -12198,7 +12132,7 @@
             <a:avLst/>
           </a:prstGeom>
           <a:solidFill>
-            <a:srgbClr val="0C1834">
+            <a:srgbClr val="F8FAFC">
               <a:alpha val="55000"/>
             </a:srgbClr>
           </a:solidFill>
@@ -12255,7 +12189,7 @@
             <a:avLst/>
           </a:prstGeom>
           <a:solidFill>
-            <a:srgbClr val="0F172A">
+            <a:srgbClr val="F8FAFC">
               <a:alpha val="28000"/>
             </a:srgbClr>
           </a:solidFill>
@@ -12322,7 +12256,7 @@
             <a:r>
               <a:rPr lang="fr-FR" sz="2400" b="1" dirty="0">
                 <a:solidFill>
-                  <a:srgbClr val="FFFFFF"/>
+                  <a:srgbClr val="0F4272"/>
                 </a:solidFill>
                 <a:latin typeface="Aptos" panose="020B0004020202020204" pitchFamily="34" charset="0"/>
               </a:rPr>
@@ -12458,7 +12392,7 @@
             <a:r>
               <a:rPr lang="fr-FR" sz="1000">
                 <a:solidFill>
-                  <a:srgbClr val="94A3B8"/>
+                  <a:srgbClr val="304152"/>
                 </a:solidFill>
                 <a:latin typeface="Aptos" panose="020B0004020202020204" pitchFamily="34" charset="0"/>
               </a:rPr>
@@ -12499,7 +12433,7 @@
             <a:r>
               <a:rPr lang="fr-FR" sz="1000" b="1">
                 <a:solidFill>
-                  <a:srgbClr val="00BCD4"/>
+                  <a:srgbClr val="304152"/>
                 </a:solidFill>
                 <a:latin typeface="Aptos" panose="020B0004020202020204" pitchFamily="34" charset="0"/>
               </a:rPr>
@@ -12569,7 +12503,7 @@
             <a:r>
               <a:rPr lang="fr-FR" sz="1300">
                 <a:solidFill>
-                  <a:srgbClr val="94A3B8"/>
+                  <a:srgbClr val="304152"/>
                 </a:solidFill>
                 <a:latin typeface="Aptos" panose="020B0004020202020204" pitchFamily="34" charset="0"/>
               </a:rPr>
@@ -12599,13 +12533,13 @@
             <a:avLst/>
           </a:prstGeom>
           <a:solidFill>
-            <a:srgbClr val="131D31">
+            <a:srgbClr val="FFFFFF">
               <a:alpha val="96000"/>
             </a:srgbClr>
           </a:solidFill>
-          <a:ln w="17145">
+          <a:ln w="12700">
             <a:solidFill>
-              <a:srgbClr val="00BCD4"/>
+              <a:srgbClr val="D3E2EC"/>
             </a:solidFill>
           </a:ln>
         </p:spPr>
@@ -12665,7 +12599,7 @@
             <a:r>
               <a:rPr lang="fr-FR" sz="1700" b="1">
                 <a:solidFill>
-                  <a:srgbClr val="00BCD4"/>
+                  <a:srgbClr val="0F4272"/>
                 </a:solidFill>
                 <a:latin typeface="Aptos" panose="020B0004020202020204" pitchFamily="34" charset="0"/>
               </a:rPr>
@@ -12705,7 +12639,7 @@
             <a:r>
               <a:rPr lang="fr-FR" sz="1000">
                 <a:solidFill>
-                  <a:srgbClr val="94A3B8"/>
+                  <a:srgbClr val="304152"/>
                 </a:solidFill>
                 <a:latin typeface="Aptos" panose="020B0004020202020204" pitchFamily="34" charset="0"/>
               </a:rPr>
@@ -12735,12 +12669,10 @@
             <a:avLst/>
           </a:prstGeom>
           <a:solidFill>
-            <a:srgbClr val="020617"/>
+            <a:srgbClr val="CBD5E1"/>
           </a:solidFill>
           <a:ln w="15240">
-            <a:solidFill>
-              <a:srgbClr val="475569"/>
-            </a:solidFill>
+            <a:noFill/>
           </a:ln>
         </p:spPr>
         <p:style>
@@ -12789,7 +12721,7 @@
             <a:avLst/>
           </a:prstGeom>
           <a:solidFill>
-            <a:srgbClr val="0F172A"/>
+            <a:srgbClr val="F8FAFC"/>
           </a:solidFill>
           <a:ln w="12700" cap="flat" cmpd="sng" algn="ctr">
             <a:noFill/>
@@ -12954,7 +12886,7 @@
             <a:avLst/>
           </a:prstGeom>
           <a:solidFill>
-            <a:srgbClr val="334155"/>
+            <a:srgbClr val="CBD5E1"/>
           </a:solidFill>
           <a:ln w="12700" cap="flat" cmpd="sng" algn="ctr">
             <a:noFill/>
@@ -13009,7 +12941,7 @@
             <a:avLst/>
           </a:prstGeom>
           <a:solidFill>
-            <a:srgbClr val="334155"/>
+            <a:srgbClr val="CBD5E1"/>
           </a:solidFill>
           <a:ln w="12700" cap="flat" cmpd="sng" algn="ctr">
             <a:noFill/>
@@ -13064,12 +12996,10 @@
             <a:avLst/>
           </a:prstGeom>
           <a:solidFill>
-            <a:srgbClr val="020617"/>
+            <a:srgbClr val="CBD5E1"/>
           </a:solidFill>
           <a:ln w="15240">
-            <a:solidFill>
-              <a:srgbClr val="475569"/>
-            </a:solidFill>
+            <a:noFill/>
           </a:ln>
         </p:spPr>
         <p:style>
@@ -13118,7 +13048,7 @@
             <a:avLst/>
           </a:prstGeom>
           <a:solidFill>
-            <a:srgbClr val="0F172A"/>
+            <a:srgbClr val="F8FAFC"/>
           </a:solidFill>
           <a:ln w="12700" cap="flat" cmpd="sng" algn="ctr">
             <a:noFill/>
@@ -13228,7 +13158,7 @@
             <a:avLst/>
           </a:prstGeom>
           <a:solidFill>
-            <a:srgbClr val="334155"/>
+            <a:srgbClr val="CBD5E1"/>
           </a:solidFill>
           <a:ln w="12700" cap="flat" cmpd="sng" algn="ctr">
             <a:noFill/>
@@ -13283,7 +13213,7 @@
             <a:avLst/>
           </a:prstGeom>
           <a:solidFill>
-            <a:srgbClr val="334155"/>
+            <a:srgbClr val="CBD5E1"/>
           </a:solidFill>
           <a:ln w="12700" cap="flat" cmpd="sng" algn="ctr">
             <a:noFill/>
@@ -13338,7 +13268,7 @@
             <a:avLst/>
           </a:prstGeom>
           <a:solidFill>
-            <a:srgbClr val="334155"/>
+            <a:srgbClr val="CBD5E1"/>
           </a:solidFill>
           <a:ln w="12700" cap="flat" cmpd="sng" algn="ctr">
             <a:noFill/>
@@ -13393,7 +13323,7 @@
             <a:avLst/>
           </a:prstGeom>
           <a:solidFill>
-            <a:srgbClr val="334155"/>
+            <a:srgbClr val="CBD5E1"/>
           </a:solidFill>
           <a:ln w="12700" cap="flat" cmpd="sng" algn="ctr">
             <a:noFill/>
@@ -13503,12 +13433,10 @@
             <a:avLst/>
           </a:prstGeom>
           <a:solidFill>
-            <a:srgbClr val="020617"/>
+            <a:srgbClr val="CBD5E1"/>
           </a:solidFill>
           <a:ln w="15240">
-            <a:solidFill>
-              <a:srgbClr val="475569"/>
-            </a:solidFill>
+            <a:noFill/>
           </a:ln>
         </p:spPr>
         <p:style>
@@ -13557,7 +13485,7 @@
             <a:avLst/>
           </a:prstGeom>
           <a:solidFill>
-            <a:srgbClr val="0F172A"/>
+            <a:srgbClr val="F8FAFC"/>
           </a:solidFill>
           <a:ln w="12700" cap="flat" cmpd="sng" algn="ctr">
             <a:noFill/>
@@ -14503,7 +14431,7 @@
             <a:r>
               <a:rPr lang="fr-FR" sz="900" b="1">
                 <a:solidFill>
-                  <a:srgbClr val="FFFFFF"/>
+                  <a:srgbClr val="304152"/>
                 </a:solidFill>
                 <a:latin typeface="Aptos" panose="020B0004020202020204" pitchFamily="34" charset="0"/>
               </a:rPr>
@@ -14544,7 +14472,7 @@
             <a:r>
               <a:rPr lang="fr-FR" sz="900" b="1">
                 <a:solidFill>
-                  <a:srgbClr val="FFFFFF"/>
+                  <a:srgbClr val="304152"/>
                 </a:solidFill>
                 <a:latin typeface="Aptos" panose="020B0004020202020204" pitchFamily="34" charset="0"/>
               </a:rPr>
@@ -14585,7 +14513,7 @@
             <a:r>
               <a:rPr lang="fr-FR" sz="900" b="1">
                 <a:solidFill>
-                  <a:srgbClr val="FFFFFF"/>
+                  <a:srgbClr val="304152"/>
                 </a:solidFill>
                 <a:latin typeface="Aptos" panose="020B0004020202020204" pitchFamily="34" charset="0"/>
               </a:rPr>
@@ -14615,13 +14543,13 @@
             <a:avLst/>
           </a:prstGeom>
           <a:solidFill>
-            <a:srgbClr val="131D31">
+            <a:srgbClr val="FFFFFF">
               <a:alpha val="96000"/>
             </a:srgbClr>
           </a:solidFill>
-          <a:ln w="17145">
+          <a:ln w="12700">
             <a:solidFill>
-              <a:srgbClr val="F59E0B"/>
+              <a:srgbClr val="D3E2EC"/>
             </a:solidFill>
           </a:ln>
         </p:spPr>
@@ -14681,7 +14609,7 @@
             <a:r>
               <a:rPr lang="fr-FR" sz="1700" b="1">
                 <a:solidFill>
-                  <a:srgbClr val="F59E0B"/>
+                  <a:srgbClr val="0F4272"/>
                 </a:solidFill>
                 <a:latin typeface="Aptos" panose="020B0004020202020204" pitchFamily="34" charset="0"/>
               </a:rPr>
@@ -14721,7 +14649,7 @@
             <a:r>
               <a:rPr lang="fr-FR" sz="1000">
                 <a:solidFill>
-                  <a:srgbClr val="94A3B8"/>
+                  <a:srgbClr val="304152"/>
                 </a:solidFill>
                 <a:latin typeface="Aptos" panose="020B0004020202020204" pitchFamily="34" charset="0"/>
               </a:rPr>
@@ -14751,12 +14679,10 @@
             <a:avLst/>
           </a:prstGeom>
           <a:solidFill>
-            <a:srgbClr val="0F172A"/>
+            <a:srgbClr val="F8FAFC"/>
           </a:solidFill>
           <a:ln w="15240">
-            <a:solidFill>
-              <a:srgbClr val="00BCD4"/>
-            </a:solidFill>
+            <a:noFill/>
           </a:ln>
         </p:spPr>
         <p:style>
@@ -15031,7 +14957,7 @@
             <a:avLst/>
           </a:prstGeom>
           <a:solidFill>
-            <a:srgbClr val="1E293B"/>
+            <a:srgbClr val="E8F5FD"/>
           </a:solidFill>
           <a:ln w="12700" cap="flat" cmpd="sng" algn="ctr">
             <a:noFill/>
@@ -15086,7 +15012,7 @@
             <a:avLst/>
           </a:prstGeom>
           <a:solidFill>
-            <a:srgbClr val="1E293B"/>
+            <a:srgbClr val="E8F5FD"/>
           </a:solidFill>
           <a:ln w="12700" cap="flat" cmpd="sng" algn="ctr">
             <a:noFill/>
@@ -15141,7 +15067,7 @@
             <a:avLst/>
           </a:prstGeom>
           <a:solidFill>
-            <a:srgbClr val="1E293B"/>
+            <a:srgbClr val="E8F5FD"/>
           </a:solidFill>
           <a:ln w="12700" cap="flat" cmpd="sng" algn="ctr">
             <a:noFill/>
@@ -15492,7 +15418,7 @@
             <a:r>
               <a:rPr lang="fr-FR" sz="900" b="1">
                 <a:solidFill>
-                  <a:srgbClr val="FFFFFF"/>
+                  <a:srgbClr val="304152"/>
                 </a:solidFill>
                 <a:latin typeface="Aptos" panose="020B0004020202020204" pitchFamily="34" charset="0"/>
               </a:rPr>
@@ -15590,7 +15516,7 @@
             <a:r>
               <a:rPr lang="fr-FR" sz="900" b="1">
                 <a:solidFill>
-                  <a:srgbClr val="FFFFFF"/>
+                  <a:srgbClr val="304152"/>
                 </a:solidFill>
                 <a:latin typeface="Aptos" panose="020B0004020202020204" pitchFamily="34" charset="0"/>
               </a:rPr>
@@ -15688,7 +15614,7 @@
             <a:r>
               <a:rPr lang="fr-FR" sz="900" b="1">
                 <a:solidFill>
-                  <a:srgbClr val="FFFFFF"/>
+                  <a:srgbClr val="304152"/>
                 </a:solidFill>
                 <a:latin typeface="Aptos" panose="020B0004020202020204" pitchFamily="34" charset="0"/>
               </a:rPr>
@@ -15813,7 +15739,7 @@
             <a:r>
               <a:rPr lang="fr-FR" sz="1000" b="1">
                 <a:solidFill>
-                  <a:srgbClr val="FFFFFF"/>
+                  <a:srgbClr val="304152"/>
                 </a:solidFill>
                 <a:latin typeface="Aptos" panose="020B0004020202020204" pitchFamily="34" charset="0"/>
               </a:rPr>
@@ -15843,13 +15769,13 @@
             <a:avLst/>
           </a:prstGeom>
           <a:solidFill>
-            <a:srgbClr val="131D31">
+            <a:srgbClr val="FFFFFF">
               <a:alpha val="96000"/>
             </a:srgbClr>
           </a:solidFill>
-          <a:ln w="17145">
+          <a:ln w="12700">
             <a:solidFill>
-              <a:srgbClr val="4361EE"/>
+              <a:srgbClr val="D3E2EC"/>
             </a:solidFill>
           </a:ln>
         </p:spPr>
@@ -15910,7 +15836,7 @@
             <a:r>
               <a:rPr lang="fr-FR" sz="1100" b="1">
                 <a:solidFill>
-                  <a:srgbClr val="FFFFFF"/>
+                  <a:srgbClr val="304152"/>
                 </a:solidFill>
                 <a:latin typeface="Aptos" panose="020B0004020202020204" pitchFamily="34" charset="0"/>
               </a:rPr>
@@ -15988,7 +15914,7 @@
             <a:r>
               <a:rPr sz="1100" b="1">
                 <a:solidFill>
-                  <a:srgbClr val="0F4272"/>
+                  <a:srgbClr val="304152"/>
                 </a:solidFill>
                 <a:latin typeface="Aptos"/>
               </a:rPr>
@@ -16023,7 +15949,7 @@
             <a:r>
               <a:rPr sz="900" b="0">
                 <a:solidFill>
-                  <a:srgbClr val="657A8C"/>
+                  <a:srgbClr val="304152"/>
                 </a:solidFill>
                 <a:latin typeface="Aptos"/>
               </a:rPr>
@@ -16190,16 +16116,12 @@
             <a:avLst/>
           </a:prstGeom>
           <a:solidFill>
-            <a:srgbClr val="0B1121">
+            <a:srgbClr val="F8FAFC">
               <a:alpha val="93000"/>
             </a:srgbClr>
           </a:solidFill>
           <a:ln w="12700">
-            <a:solidFill>
-              <a:srgbClr val="0B1121">
-                <a:alpha val="0"/>
-              </a:srgbClr>
-            </a:solidFill>
+            <a:noFill/>
             <a:prstDash val="solid"/>
           </a:ln>
         </p:spPr>
@@ -16240,7 +16162,7 @@
             <a:r>
               <a:rPr lang="en-US" sz="2900" b="1" dirty="0">
                 <a:solidFill>
-                  <a:srgbClr val="FFFFFF"/>
+                  <a:srgbClr val="0F4272"/>
                 </a:solidFill>
               </a:rPr>
               <a:t>Conclusion &amp; perspectives</a:t>
@@ -16355,12 +16277,10 @@
             <a:avLst/>
           </a:prstGeom>
           <a:solidFill>
-            <a:srgbClr val="334155"/>
+            <a:srgbClr val="CBD5E1"/>
           </a:solidFill>
           <a:ln w="12700">
-            <a:solidFill>
-              <a:srgbClr val="334155"/>
-            </a:solidFill>
+            <a:noFill/>
             <a:prstDash val="solid"/>
           </a:ln>
         </p:spPr>
@@ -16399,7 +16319,7 @@
             <a:r>
               <a:rPr lang="en-US" sz="1600" dirty="0">
                 <a:solidFill>
-                  <a:srgbClr val="94A3B8"/>
+                  <a:srgbClr val="5A6E80"/>
                 </a:solidFill>
               </a:rPr>
               <a:t>EduTrack — Projet de Licence 3</a:t>
@@ -16435,7 +16355,7 @@
             <a:r>
               <a:rPr lang="en-US" sz="1600" b="1" dirty="0">
                 <a:solidFill>
-                  <a:srgbClr val="06B6D4"/>
+                  <a:srgbClr val="5A6E80"/>
                 </a:solidFill>
               </a:rPr>
               <a:t>8 / 9</a:t>
@@ -16471,7 +16391,7 @@
             <a:r>
               <a:rPr lang="en-US" sz="2200" b="1" dirty="0">
                 <a:solidFill>
-                  <a:srgbClr val="10B981"/>
+                  <a:srgbClr val="0F4272"/>
                 </a:solidFill>
               </a:rPr>
               <a:t>Conclusion</a:t>
@@ -16497,13 +16417,13 @@
             </a:avLst>
           </a:prstGeom>
           <a:solidFill>
-            <a:srgbClr val="172033">
+            <a:srgbClr val="FFFFFF">
               <a:alpha val="96000"/>
             </a:srgbClr>
           </a:solidFill>
-          <a:ln w="14605">
+          <a:ln w="12700">
             <a:solidFill>
-              <a:srgbClr val="10B981"/>
+              <a:srgbClr val="D3E2EC"/>
             </a:solidFill>
             <a:prstDash val="solid"/>
           </a:ln>
@@ -16574,7 +16494,7 @@
             <a:r>
               <a:rPr lang="en-US" sz="1700" b="1" dirty="0">
                 <a:solidFill>
-                  <a:srgbClr val="FFFFFF"/>
+                  <a:srgbClr val="0F4272"/>
                 </a:solidFill>
               </a:rPr>
               <a:t>Suivi centralisé</a:t>
@@ -16612,7 +16532,7 @@
             <a:r>
               <a:rPr lang="en-US" sz="1250" dirty="0">
                 <a:solidFill>
-                  <a:srgbClr val="94A3B8"/>
+                  <a:srgbClr val="304152"/>
                 </a:solidFill>
               </a:rPr>
               <a:t>Données regroupées</a:t>
@@ -16638,13 +16558,13 @@
             </a:avLst>
           </a:prstGeom>
           <a:solidFill>
-            <a:srgbClr val="172033">
+            <a:srgbClr val="FFFFFF">
               <a:alpha val="96000"/>
             </a:srgbClr>
           </a:solidFill>
-          <a:ln w="14605">
+          <a:ln w="12700">
             <a:solidFill>
-              <a:srgbClr val="06B6D4"/>
+              <a:srgbClr val="D3E2EC"/>
             </a:solidFill>
             <a:prstDash val="solid"/>
           </a:ln>
@@ -16715,7 +16635,7 @@
             <a:r>
               <a:rPr lang="en-US" sz="1700" b="1" dirty="0">
                 <a:solidFill>
-                  <a:srgbClr val="FFFFFF"/>
+                  <a:srgbClr val="0F4272"/>
                 </a:solidFill>
               </a:rPr>
               <a:t>Émargement fiable</a:t>
@@ -16753,7 +16673,7 @@
             <a:r>
               <a:rPr lang="en-US" sz="1250" dirty="0">
                 <a:solidFill>
-                  <a:srgbClr val="94A3B8"/>
+                  <a:srgbClr val="304152"/>
                 </a:solidFill>
               </a:rPr>
               <a:t>Émargement traçable</a:t>
@@ -16779,13 +16699,13 @@
             </a:avLst>
           </a:prstGeom>
           <a:solidFill>
-            <a:srgbClr val="172033">
+            <a:srgbClr val="FFFFFF">
               <a:alpha val="96000"/>
             </a:srgbClr>
           </a:solidFill>
-          <a:ln w="14605">
+          <a:ln w="12700">
             <a:solidFill>
-              <a:srgbClr val="F59E0B"/>
+              <a:srgbClr val="D3E2EC"/>
             </a:solidFill>
             <a:prstDash val="solid"/>
           </a:ln>
@@ -16827,7 +16747,7 @@
             <a:r>
               <a:rPr lang="en-US" sz="1700" b="1" dirty="0">
                 <a:solidFill>
-                  <a:srgbClr val="FFFFFF"/>
+                  <a:srgbClr val="0F4272"/>
                 </a:solidFill>
               </a:rPr>
               <a:t>Honoraires</a:t>
@@ -16865,7 +16785,7 @@
             <a:r>
               <a:rPr lang="en-US" sz="1250" dirty="0">
                 <a:solidFill>
-                  <a:srgbClr val="94A3B8"/>
+                  <a:srgbClr val="304152"/>
                 </a:solidFill>
               </a:rPr>
               <a:t>Calcul automatisé</a:t>
@@ -16889,12 +16809,10 @@
             <a:avLst/>
           </a:prstGeom>
           <a:solidFill>
-            <a:srgbClr val="334155"/>
+            <a:srgbClr val="CBD5E1"/>
           </a:solidFill>
           <a:ln w="12700">
-            <a:solidFill>
-              <a:srgbClr val="334155"/>
-            </a:solidFill>
+            <a:noFill/>
             <a:prstDash val="solid"/>
           </a:ln>
         </p:spPr>
@@ -16933,7 +16851,7 @@
             <a:r>
               <a:rPr lang="en-US" sz="2200" b="1" dirty="0">
                 <a:solidFill>
-                  <a:srgbClr val="06B6D4"/>
+                  <a:srgbClr val="0F4272"/>
                 </a:solidFill>
               </a:rPr>
               <a:t>Perspectives</a:t>
@@ -16959,13 +16877,13 @@
             </a:avLst>
           </a:prstGeom>
           <a:solidFill>
-            <a:srgbClr val="172033">
+            <a:srgbClr val="FFFFFF">
               <a:alpha val="96000"/>
             </a:srgbClr>
           </a:solidFill>
-          <a:ln w="14605">
+          <a:ln w="12700">
             <a:solidFill>
-              <a:srgbClr val="3B82F6"/>
+              <a:srgbClr val="D3E2EC"/>
             </a:solidFill>
             <a:prstDash val="solid"/>
           </a:ln>
@@ -17036,7 +16954,7 @@
             <a:r>
               <a:rPr lang="en-US" sz="1700" b="1" dirty="0">
                 <a:solidFill>
-                  <a:srgbClr val="FFFFFF"/>
+                  <a:srgbClr val="0F4272"/>
                 </a:solidFill>
               </a:rPr>
               <a:t>Module étudiant</a:t>
@@ -17074,7 +16992,7 @@
             <a:r>
               <a:rPr lang="en-US" sz="1250" dirty="0">
                 <a:solidFill>
-                  <a:srgbClr val="94A3B8"/>
+                  <a:srgbClr val="304152"/>
                 </a:solidFill>
               </a:rPr>
               <a:t>Espace dédié</a:t>
@@ -17100,13 +17018,13 @@
             </a:avLst>
           </a:prstGeom>
           <a:solidFill>
-            <a:srgbClr val="172033">
+            <a:srgbClr val="FFFFFF">
               <a:alpha val="96000"/>
             </a:srgbClr>
           </a:solidFill>
-          <a:ln w="14605">
+          <a:ln w="12700">
             <a:solidFill>
-              <a:srgbClr val="EF4444"/>
+              <a:srgbClr val="D3E2EC"/>
             </a:solidFill>
             <a:prstDash val="solid"/>
           </a:ln>
@@ -17177,7 +17095,7 @@
             <a:r>
               <a:rPr lang="en-US" sz="1700" b="1" dirty="0">
                 <a:solidFill>
-                  <a:srgbClr val="FFFFFF"/>
+                  <a:srgbClr val="0F4272"/>
                 </a:solidFill>
               </a:rPr>
               <a:t>Notifications</a:t>
@@ -17215,7 +17133,7 @@
             <a:r>
               <a:rPr lang="en-US" sz="1250" dirty="0">
                 <a:solidFill>
-                  <a:srgbClr val="94A3B8"/>
+                  <a:srgbClr val="304152"/>
                 </a:solidFill>
               </a:rPr>
               <a:t>Email / SMS</a:t>
@@ -17241,13 +17159,13 @@
             </a:avLst>
           </a:prstGeom>
           <a:solidFill>
-            <a:srgbClr val="172033">
+            <a:srgbClr val="FFFFFF">
               <a:alpha val="96000"/>
             </a:srgbClr>
           </a:solidFill>
-          <a:ln w="14605">
+          <a:ln w="12700">
             <a:solidFill>
-              <a:srgbClr val="8B5CF6"/>
+              <a:srgbClr val="D3E2EC"/>
             </a:solidFill>
             <a:prstDash val="solid"/>
           </a:ln>
@@ -17318,7 +17236,7 @@
             <a:r>
               <a:rPr lang="en-US" sz="1700" b="1" dirty="0">
                 <a:solidFill>
-                  <a:srgbClr val="FFFFFF"/>
+                  <a:srgbClr val="0F4272"/>
                 </a:solidFill>
               </a:rPr>
               <a:t>Paiement</a:t>
@@ -17356,7 +17274,7 @@
             <a:r>
               <a:rPr lang="en-US" sz="1250" dirty="0">
                 <a:solidFill>
-                  <a:srgbClr val="94A3B8"/>
+                  <a:srgbClr val="304152"/>
                 </a:solidFill>
               </a:rPr>
               <a:t>Mobile money</a:t>
@@ -17380,11 +17298,11 @@
             <a:avLst/>
           </a:prstGeom>
           <a:solidFill>
-            <a:srgbClr val="172033"/>
-          </a:solidFill>
-          <a:ln w="14605">
+            <a:srgbClr val="FFFFFF"/>
+          </a:solidFill>
+          <a:ln w="12700">
             <a:solidFill>
-              <a:srgbClr val="06B6D4"/>
+              <a:srgbClr val="D3E2EC"/>
             </a:solidFill>
           </a:ln>
         </p:spPr>
@@ -17436,7 +17354,7 @@
             <a:r>
               <a:rPr sz="1700" b="1">
                 <a:solidFill>
-                  <a:srgbClr val="FFFFFF"/>
+                  <a:srgbClr val="0F4272"/>
                 </a:solidFill>
               </a:rPr>
               <a:t>Signature</a:t>
@@ -17469,7 +17387,7 @@
             <a:r>
               <a:rPr sz="1700" b="0">
                 <a:solidFill>
-                  <a:srgbClr val="FFFFFF"/>
+                  <a:srgbClr val="304152"/>
                 </a:solidFill>
               </a:rPr>
               <a:t>Enseignants</a:t>
@@ -17594,7 +17512,7 @@
             <a:r>
               <a:rPr sz="1100" b="1">
                 <a:solidFill>
-                  <a:srgbClr val="0F4272"/>
+                  <a:srgbClr val="304152"/>
                 </a:solidFill>
                 <a:latin typeface="Aptos"/>
               </a:rPr>
@@ -17629,7 +17547,7 @@
             <a:r>
               <a:rPr sz="900" b="0">
                 <a:solidFill>
-                  <a:srgbClr val="657A8C"/>
+                  <a:srgbClr val="304152"/>
                 </a:solidFill>
                 <a:latin typeface="Aptos"/>
               </a:rPr>
@@ -18424,6 +18342,41 @@
                 <a:latin typeface="Aptos"/>
               </a:rPr>
               <a:t>Nous serons ravis d’échanger avec vous.</a:t>
+            </a:r>
+          </a:p>
+        </p:txBody>
+      </p:sp>
+      <p:sp>
+        <p:nvSpPr>
+          <p:cNvPr id="200" name="TextBox 199"/>
+          <p:cNvSpPr txBox="1"/>
+          <p:nvPr/>
+        </p:nvSpPr>
+        <p:spPr>
+          <a:xfrm>
+            <a:off x="10716768" y="155448"/>
+            <a:ext cx="713232" cy="237744"/>
+          </a:xfrm>
+          <a:prstGeom prst="rect">
+            <a:avLst/>
+          </a:prstGeom>
+          <a:noFill/>
+        </p:spPr>
+        <p:txBody>
+          <a:bodyPr wrap="none" lIns="0" rIns="0" tIns="0" bIns="0">
+            <a:spAutoFit/>
+          </a:bodyPr>
+          <a:lstStyle/>
+          <a:p>
+            <a:pPr algn="r"/>
+            <a:r>
+              <a:rPr sz="900">
+                <a:solidFill>
+                  <a:srgbClr val="5A6E80"/>
+                </a:solidFill>
+                <a:latin typeface="Aptos"/>
+              </a:rPr>
+              <a:t>09 / 09</a:t>
             </a:r>
           </a:p>
         </p:txBody>

</xml_diff>